<commit_message>
Deck and results: labeller / lab hold-out experiments
Adds the symmetric hold-out (4 hardest Stav sessions, 4 training pools) and 3
random draws of 4 held-out sessions per lab. Stav sessions are best predicted
by a Stav-trained model in 4/4 tests (+0.014 to +0.031 F1); on the hardest
Inbar sessions an Inbar-trained model wins by +0.041, on random Inbar draws the
two tie (-0.011 to +0.001) with half the training data. Three new slides
(finding, experiment design, full table) and updated recommendations.

Co-Authored-By: Claude Opus 5.5 (1M context) <noreply@anthropic.com>
</commit_message>
<xml_diff>
--- a/results/suite2p_roi_classification_summary.pptx
+++ b/results/suite2p_roi_classification_summary.pptx
@@ -18,9 +18,12 @@
     <p:sldId id="266" r:id="rId12"/>
     <p:sldId id="267" r:id="rId13"/>
     <p:sldId id="268" r:id="rId14"/>
+    <p:sldId id="269" r:id="rId15"/>
+    <p:sldId id="270" r:id="rId16"/>
+    <p:sldId id="271" r:id="rId17"/>
   </p:sldIdLst>
   <p:notesMasterIdLst>
-    <p:notesMasterId r:id="rId15"/>
+    <p:notesMasterId r:id="rId18"/>
   </p:notesMasterIdLst>
   <p:sldSz cx="12192000" cy="6858000"/>
   <p:notesSz cx="6858000" cy="12192000"/>
@@ -119,19 +122,19 @@
   <p:extLst>
     <p:ext uri="{521415D9-36F7-43E2-AB2F-B90AF26B5E84}">
       <p14:sectionLst xmlns:p14="http://schemas.microsoft.com/office/powerpoint/2010/main">
-        <p14:section name="Overview" id="{7896b4a9-2eb2-9493-e4f4-55271f081c49}">
+        <p14:section name="Overview" id="{c7c191e7-ea14-12f3-0235-c88a6d6834af}">
           <p14:sldIdLst>
             <p14:sldId id="256"/>
             <p14:sldId id="257"/>
           </p14:sldIdLst>
         </p14:section>
-        <p14:section name="Data and evaluation" id="{b1ecea18-81b2-90f9-e058-c7c5dc2bd4bf}">
+        <p14:section name="Data and evaluation" id="{2e41463d-2fe1-2c97-1f41-8e4377e1b978}">
           <p14:sldIdLst>
             <p14:sldId id="258"/>
             <p14:sldId id="259"/>
           </p14:sldIdLst>
         </p14:section>
-        <p14:section name="Image features" id="{b14b790a-46bc-c06a-0f25-cf1128d47d42}">
+        <p14:section name="Image features" id="{7acb0ec1-4d6c-b350-c6f9-e6e5218aaa37}">
           <p14:sldIdLst>
             <p14:sldId id="260"/>
             <p14:sldId id="261"/>
@@ -139,21 +142,24 @@
             <p14:sldId id="263"/>
           </p14:sldIdLst>
         </p14:section>
-        <p14:section name="Neural networks and alternatives" id="{2c08894f-c168-347f-6535-d0e9652643b1}">
+        <p14:section name="Neural networks and alternatives" id="{f39e3c94-5f0d-e7e7-44c2-d9da65484fd1}">
           <p14:sldIdLst>
             <p14:sldId id="264"/>
             <p14:sldId id="265"/>
           </p14:sldIdLst>
         </p14:section>
-        <p14:section name="Labels" id="{1828497e-1315-9882-d278-06070a6e10b8}">
+        <p14:section name="Labels" id="{c9ebb9e3-90ed-71a1-46fe-37b6358c25f0}">
           <p14:sldIdLst>
             <p14:sldId id="266"/>
+            <p14:sldId id="267"/>
+            <p14:sldId id="268"/>
+            <p14:sldId id="269"/>
           </p14:sldIdLst>
         </p14:section>
-        <p14:section name="Next steps" id="{d970d3ac-5d59-1375-98a8-d9c8616ef240}">
+        <p14:section name="Next steps" id="{35df7b02-f4a3-697c-c1b1-8e543222a7ab}">
           <p14:sldIdLst>
-            <p14:sldId id="267"/>
-            <p14:sldId id="268"/>
+            <p14:sldId id="270"/>
+            <p14:sldId id="271"/>
           </p14:sldIdLst>
         </p14:section>
       </p14:sectionLst>
@@ -2182,6 +2188,396 @@
   <c:date1904 val="0"/>
   <c:roundedCorners val="1"/>
   <c:chart>
+    <c:title>
+      <c:tx>
+        <c:rich>
+          <a:bodyPr/>
+          <a:lstStyle/>
+          <a:p>
+            <a:pPr>
+              <a:defRPr sz="1300" b="0" i="0" u="none" strike="noStrike">
+                <a:solidFill>
+                  <a:srgbClr val="6B7B88"/>
+                </a:solidFill>
+                <a:latin typeface="+mn-lt"/>
+              </a:defRPr>
+            </a:pPr>
+            <a:r>
+              <a:rPr sz="1300" b="0" i="0" u="none" strike="noStrike">
+                <a:solidFill>
+                  <a:srgbClr val="6B7B88"/>
+                </a:solidFill>
+                <a:latin typeface="+mn-lt"/>
+              </a:rPr>
+              <a:t>F1 trained on own lab minus F1 trained on the other lab</a:t>
+            </a:r>
+          </a:p>
+        </c:rich>
+      </c:tx>
+      <c:layout/>
+      <c:overlay val="0"/>
+    </c:title>
+    <c:autoTitleDeleted val="0"/>
+    <c:plotArea>
+      <c:layout/>
+      <c:barChart>
+        <c:barDir val="bar"/>
+        <c:grouping val="clustered"/>
+        <c:varyColors val="0"/>
+        <c:ser>
+          <c:idx val="0"/>
+          <c:order val="0"/>
+          <c:tx>
+            <c:strRef>
+              <c:f>Sheet1!$B$1</c:f>
+              <c:strCache>
+                <c:ptCount val="1"/>
+                <c:pt idx="0">
+                  <c:v>Own-lab advantage</c:v>
+                </c:pt>
+              </c:strCache>
+            </c:strRef>
+          </c:tx>
+          <c:spPr>
+            <a:solidFill>
+              <a:srgbClr val="12A37D"/>
+            </a:solidFill>
+            <a:effectLst/>
+          </c:spPr>
+          <c:invertIfNegative val="0"/>
+          <c:dLbls>
+            <c:numFmt formatCode="+0.000;-0.000;0.000" sourceLinked="0"/>
+            <c:txPr>
+              <a:bodyPr/>
+              <a:lstStyle/>
+              <a:p>
+                <a:pPr>
+                  <a:defRPr b="0" i="0" strike="noStrike" sz="1100" u="none">
+                    <a:solidFill>
+                      <a:srgbClr val="1B2631"/>
+                    </a:solidFill>
+                    <a:latin typeface="+mn-lt"/>
+                  </a:defRPr>
+                </a:pPr>
+              </a:p>
+            </c:txPr>
+            <c:showLegendKey val="0"/>
+            <c:showVal val="1"/>
+            <c:showCatName val="0"/>
+            <c:showSerName val="0"/>
+            <c:showPercent val="0"/>
+            <c:showBubbleSize val="0"/>
+            <c:showLeaderLines val="0"/>
+          </c:dLbls>
+          <c:dPt>
+            <c:idx val="0"/>
+            <c:invertIfNegative val="0"/>
+            <c:bubble3D val="0"/>
+            <c:spPr>
+              <a:solidFill>
+                <a:srgbClr val="12A37D"/>
+              </a:solidFill>
+              <a:effectLst/>
+            </c:spPr>
+          </c:dPt>
+          <c:dPt>
+            <c:idx val="1"/>
+            <c:invertIfNegative val="0"/>
+            <c:bubble3D val="0"/>
+            <c:spPr>
+              <a:solidFill>
+                <a:srgbClr val="12A37D"/>
+              </a:solidFill>
+              <a:effectLst/>
+            </c:spPr>
+          </c:dPt>
+          <c:dPt>
+            <c:idx val="2"/>
+            <c:invertIfNegative val="0"/>
+            <c:bubble3D val="0"/>
+            <c:spPr>
+              <a:solidFill>
+                <a:srgbClr val="12A37D"/>
+              </a:solidFill>
+              <a:effectLst/>
+            </c:spPr>
+          </c:dPt>
+          <c:dPt>
+            <c:idx val="3"/>
+            <c:invertIfNegative val="0"/>
+            <c:bubble3D val="0"/>
+            <c:spPr>
+              <a:solidFill>
+                <a:srgbClr val="12A37D"/>
+              </a:solidFill>
+              <a:effectLst/>
+            </c:spPr>
+          </c:dPt>
+          <c:dPt>
+            <c:idx val="4"/>
+            <c:invertIfNegative val="0"/>
+            <c:bubble3D val="0"/>
+            <c:spPr>
+              <a:solidFill>
+                <a:srgbClr val="12A37D"/>
+              </a:solidFill>
+              <a:effectLst/>
+            </c:spPr>
+          </c:dPt>
+          <c:dPt>
+            <c:idx val="5"/>
+            <c:invertIfNegative val="0"/>
+            <c:bubble3D val="0"/>
+            <c:spPr>
+              <a:solidFill>
+                <a:srgbClr val="C44536"/>
+              </a:solidFill>
+              <a:effectLst/>
+            </c:spPr>
+          </c:dPt>
+          <c:dPt>
+            <c:idx val="6"/>
+            <c:invertIfNegative val="0"/>
+            <c:bubble3D val="0"/>
+            <c:spPr>
+              <a:solidFill>
+                <a:srgbClr val="12A37D"/>
+              </a:solidFill>
+              <a:effectLst/>
+            </c:spPr>
+          </c:dPt>
+          <c:dPt>
+            <c:idx val="7"/>
+            <c:invertIfNegative val="0"/>
+            <c:bubble3D val="0"/>
+            <c:spPr>
+              <a:solidFill>
+                <a:srgbClr val="C44536"/>
+              </a:solidFill>
+              <a:effectLst/>
+            </c:spPr>
+          </c:dPt>
+          <c:cat>
+            <c:multiLvlStrRef>
+              <c:f>Sheet1!$A$2:$A$9</c:f>
+              <c:multiLvlStrCache>
+                <c:ptCount val="8"/>
+                <c:lvl>
+                  <c:pt idx="0">
+                    <c:v>Stav: 4 hardest</c:v>
+                  </c:pt>
+                  <c:pt idx="1">
+                    <c:v>Stav: random draw 1</c:v>
+                  </c:pt>
+                  <c:pt idx="2">
+                    <c:v>Stav: random draw 2</c:v>
+                  </c:pt>
+                  <c:pt idx="3">
+                    <c:v>Stav: random draw 3</c:v>
+                  </c:pt>
+                  <c:pt idx="4">
+                    <c:v>Inbar: 4 hardest</c:v>
+                  </c:pt>
+                  <c:pt idx="5">
+                    <c:v>Inbar: random draw 1</c:v>
+                  </c:pt>
+                  <c:pt idx="6">
+                    <c:v>Inbar: random draw 2</c:v>
+                  </c:pt>
+                  <c:pt idx="7">
+                    <c:v>Inbar: random draw 3</c:v>
+                  </c:pt>
+                </c:lvl>
+              </c:multiLvlStrCache>
+            </c:multiLvlStrRef>
+          </c:cat>
+          <c:val>
+            <c:numRef>
+              <c:f>Sheet1!$B$2:$B$9</c:f>
+              <c:numCache>
+                <c:formatCode>General</c:formatCode>
+                <c:ptCount val="8"/>
+                <c:pt idx="0">
+                  <c:v>0.025</c:v>
+                </c:pt>
+                <c:pt idx="1">
+                  <c:v>0.014</c:v>
+                </c:pt>
+                <c:pt idx="2">
+                  <c:v>0.031</c:v>
+                </c:pt>
+                <c:pt idx="3">
+                  <c:v>0.022</c:v>
+                </c:pt>
+                <c:pt idx="4">
+                  <c:v>0.041</c:v>
+                </c:pt>
+                <c:pt idx="5">
+                  <c:v>-0.011</c:v>
+                </c:pt>
+                <c:pt idx="6">
+                  <c:v>0.001</c:v>
+                </c:pt>
+                <c:pt idx="7">
+                  <c:v>-0.009</c:v>
+                </c:pt>
+              </c:numCache>
+            </c:numRef>
+          </c:val>
+        </c:ser>
+        <c:dLbls>
+          <c:numFmt formatCode="+0.000;-0.000;0.000" sourceLinked="0"/>
+          <c:txPr>
+            <a:bodyPr/>
+            <a:lstStyle/>
+            <a:p>
+              <a:pPr>
+                <a:defRPr b="0" i="0" strike="noStrike" sz="1100" u="none">
+                  <a:solidFill>
+                    <a:srgbClr val="1B2631"/>
+                  </a:solidFill>
+                  <a:latin typeface="+mn-lt"/>
+                </a:defRPr>
+              </a:pPr>
+            </a:p>
+          </c:txPr>
+          <c:showLegendKey val="0"/>
+          <c:showVal val="1"/>
+          <c:showCatName val="0"/>
+          <c:showSerName val="0"/>
+          <c:showPercent val="0"/>
+          <c:showBubbleSize val="0"/>
+          <c:showLeaderLines val="0"/>
+        </c:dLbls>
+        <c:gapWidth val="40"/>
+        <c:overlap val="0"/>
+        <c:axId val="2094734554"/>
+        <c:axId val="2094734552"/>
+        <c:axId val="2094734556"/>
+      </c:barChart>
+      <c:catAx>
+        <c:axId val="2094734554"/>
+        <c:scaling>
+          <c:orientation val="maxMin"/>
+        </c:scaling>
+        <c:delete val="0"/>
+        <c:axPos val="l"/>
+        <c:numFmt formatCode="General" sourceLinked="1"/>
+        <c:majorTickMark val="out"/>
+        <c:minorTickMark val="none"/>
+        <c:tickLblPos val="low"/>
+        <c:spPr>
+          <a:ln w="12700" cap="flat">
+            <a:solidFill>
+              <a:srgbClr val="888888"/>
+            </a:solidFill>
+            <a:prstDash val="solid"/>
+            <a:round/>
+          </a:ln>
+        </c:spPr>
+        <c:txPr>
+          <a:bodyPr/>
+          <a:lstStyle/>
+          <a:p>
+            <a:pPr>
+              <a:defRPr sz="1200" b="0" i="0" u="none" strike="noStrike">
+                <a:solidFill>
+                  <a:srgbClr val="1B2631"/>
+                </a:solidFill>
+                <a:latin typeface="+mn-lt"/>
+              </a:defRPr>
+            </a:pPr>
+            <a:endParaRPr lang="en-US"/>
+          </a:p>
+        </c:txPr>
+        <c:crossAx val="2094734552"/>
+        <c:crosses val="autoZero"/>
+        <c:auto val="1"/>
+        <c:lblAlgn val="ctr"/>
+        <c:noMultiLvlLbl val="1"/>
+      </c:catAx>
+      <c:valAx>
+        <c:axId val="2094734552"/>
+        <c:scaling>
+          <c:orientation val="minMax"/>
+          <c:max val="0.05"/>
+          <c:min val="-0.02"/>
+        </c:scaling>
+        <c:delete val="0"/>
+        <c:axPos val="b"/>
+        <c:majorGridlines>
+          <c:spPr>
+            <a:ln w="9525" cap="flat">
+              <a:solidFill>
+                <a:srgbClr val="DDE5E4"/>
+              </a:solidFill>
+              <a:prstDash val="solid"/>
+              <a:round/>
+            </a:ln>
+          </c:spPr>
+        </c:majorGridlines>
+        <c:numFmt formatCode="+0.00;-0.00;0" sourceLinked="0"/>
+        <c:majorTickMark val="out"/>
+        <c:minorTickMark val="none"/>
+        <c:tickLblPos val="low"/>
+        <c:spPr>
+          <a:ln w="12700" cap="flat">
+            <a:solidFill>
+              <a:srgbClr val="888888"/>
+            </a:solidFill>
+            <a:prstDash val="solid"/>
+            <a:round/>
+          </a:ln>
+        </c:spPr>
+        <c:txPr>
+          <a:bodyPr/>
+          <a:lstStyle/>
+          <a:p>
+            <a:pPr>
+              <a:defRPr sz="1100" b="0" i="0" u="none" strike="noStrike">
+                <a:solidFill>
+                  <a:srgbClr val="6B7B88"/>
+                </a:solidFill>
+                <a:latin typeface="+mn-lt"/>
+              </a:defRPr>
+            </a:pPr>
+            <a:endParaRPr lang="en-US"/>
+          </a:p>
+        </c:txPr>
+        <c:crossAx val="2094734554"/>
+        <c:crosses val="autoZero"/>
+        <c:crossBetween val="between"/>
+        <c:majorUnit val="0.01"/>
+      </c:valAx>
+      <c:spPr>
+        <a:noFill/>
+        <a:ln>
+          <a:noFill/>
+        </a:ln>
+        <a:effectLst/>
+      </c:spPr>
+    </c:plotArea>
+    <c:plotVisOnly val="1"/>
+    <c:dispBlanksAs val="span"/>
+  </c:chart>
+  <c:spPr>
+    <a:noFill/>
+    <a:ln>
+      <a:noFill/>
+    </a:ln>
+    <a:effectLst/>
+  </c:spPr>
+  <c:externalData r:id="rId1">
+    <c:autoUpdate val="0"/>
+  </c:externalData>
+</c:chartSpace>
+</file>
+
+<file path=ppt/charts/chart7.xml><?xml version="1.0" encoding="utf-8"?>
+<c:chartSpace xmlns:c="http://schemas.openxmlformats.org/drawingml/2006/chart" xmlns:a="http://schemas.openxmlformats.org/drawingml/2006/main" xmlns:r="http://schemas.openxmlformats.org/officeDocument/2006/relationships">
+  <c:date1904 val="0"/>
+  <c:roundedCorners val="1"/>
+  <c:chart>
     <c:autoTitleDeleted val="1"/>
     <c:plotArea>
       <c:layout/>
@@ -3118,7 +3514,7 @@
           <a:p>
             <a:r>
               <a:rPr lang="en-US" dirty="0"/>
-              <a:t>Hold-out experiment: train on Stav only, Inbar only, or both, and test on Inbar3, Inbar12, inbar1 and Inbar9, with the threshold picked by inner CV on the training sessions. Mirror check on Stav14. Inbar12 and Inbar9 are well calibrated; Inbar3, inbar1 and Stav14 rank well but their labellers drew the line more or less strictly than the rest.</a:t>
+              <a:t>Each bar is one hold-out experiment: 4 sessions of one lab are held out, and two models are trained, one on the remaining sessions of that lab and one on the other lab only. Same 44 features, same LightGBM settings; the threshold is chosen by cross-validation on the training sessions only. Positive = the model trained on the same lab's labels did better.</a:t>
             </a:r>
             <a:endParaRPr lang="en-US" dirty="0"/>
           </a:p>
@@ -3206,7 +3602,7 @@
           <a:p>
             <a:r>
               <a:rPr lang="en-US" dirty="0"/>
-              <a:t>Tested on copies of Inbar2 and Stav11 (end to end) and Stav1 (fallback), with the original iscell files checksummed before and after. Found along the way: the regular model computes some features differently at training and inference time.</a:t>
+              <a:t>Stav pool: 17 sessions (13 when 4 are held out). Inbar pool: 12 sessions (8 when 4 are held out). Scripts: scripts/holdout_eval.py; results in results/labeller_experiments.md.</a:t>
             </a:r>
             <a:endParaRPr lang="en-US" dirty="0"/>
           </a:p>
@@ -3294,7 +3690,7 @@
           <a:p>
             <a:r>
               <a:rPr lang="en-US" dirty="0"/>
-              <a:t>Code, results and this deck are on the branch feat/image-features in AddadyTom/suite2p-classification (results/REPORT.md and results/*.md for the full tables).</a:t>
+              <a:t>Bold = the better of the two training pools for that held-out set. Own-lab advantage = F1(trained on the same lab) minus F1(trained on the other lab).</a:t>
             </a:r>
             <a:endParaRPr lang="en-US" dirty="0"/>
           </a:p>
@@ -3318,6 +3714,270 @@
             <a:fld id="{F7021451-1387-4CA6-816F-3879F97B5CBC}" type="slidenum">
               <a:rPr lang="en-US"/>
               <a:t>13</a:t>
+            </a:fld>
+            <a:endParaRPr lang="en-US"/>
+          </a:p>
+        </p:txBody>
+      </p:sp>
+    </p:spTree>
+    <p:extLst>
+      <p:ext uri="{BB962C8B-B14F-4D97-AF65-F5344CB8AC3E}">
+        <p14:creationId xmlns:p14="http://schemas.microsoft.com/office/powerpoint/2010/main" val="1024086991"/>
+      </p:ext>
+    </p:extLst>
+  </p:cSld>
+  <p:clrMapOvr>
+    <a:masterClrMapping/>
+  </p:clrMapOvr>
+</p:notes>
+</file>
+
+<file path=ppt/notesSlides/notesSlide14.xml><?xml version="1.0" encoding="utf-8"?>
+<p:notes xmlns:a="http://schemas.openxmlformats.org/drawingml/2006/main" xmlns:r="http://schemas.openxmlformats.org/officeDocument/2006/relationships" xmlns:p="http://schemas.openxmlformats.org/presentationml/2006/main">
+  <p:cSld>
+    <p:spTree>
+      <p:nvGrpSpPr>
+        <p:cNvPr id="1" name=""/>
+        <p:cNvGrpSpPr/>
+        <p:nvPr/>
+      </p:nvGrpSpPr>
+      <p:grpSpPr>
+        <a:xfrm>
+          <a:off x="0" y="0"/>
+          <a:ext cx="0" cy="0"/>
+          <a:chOff x="0" y="0"/>
+          <a:chExt cx="0" cy="0"/>
+        </a:xfrm>
+      </p:grpSpPr>
+      <p:sp>
+        <p:nvSpPr>
+          <p:cNvPr id="2" name="Slide Image Placeholder 1"/>
+          <p:cNvSpPr>
+            <a:spLocks noGrp="1" noRot="1" noChangeAspect="1"/>
+          </p:cNvSpPr>
+          <p:nvPr>
+            <p:ph type="sldImg"/>
+          </p:nvPr>
+        </p:nvSpPr>
+        <p:spPr/>
+      </p:sp>
+      <p:sp>
+        <p:nvSpPr>
+          <p:cNvPr id="3" name="Notes Placeholder 2"/>
+          <p:cNvSpPr>
+            <a:spLocks noGrp="1"/>
+          </p:cNvSpPr>
+          <p:nvPr>
+            <p:ph type="body" idx="1"/>
+          </p:nvPr>
+        </p:nvSpPr>
+        <p:spPr/>
+        <p:txBody>
+          <a:bodyPr/>
+          <a:lstStyle/>
+          <a:p>
+            <a:r>
+              <a:rPr lang="en-US" dirty="0"/>
+              <a:t>Hold-out experiment: train on Stav only, Inbar only, or both, and test on Inbar3, Inbar12, inbar1 and Inbar9, with the threshold picked by inner CV on the training sessions. Mirror check on Stav14. Inbar12 and Inbar9 are well calibrated; Inbar3, inbar1 and Stav14 rank well but their labellers drew the line more or less strictly than the rest.</a:t>
+            </a:r>
+            <a:endParaRPr lang="en-US" dirty="0"/>
+          </a:p>
+        </p:txBody>
+      </p:sp>
+      <p:sp>
+        <p:nvSpPr>
+          <p:cNvPr id="4" name="Slide Number Placeholder 3"/>
+          <p:cNvSpPr>
+            <a:spLocks noGrp="1"/>
+          </p:cNvSpPr>
+          <p:nvPr>
+            <p:ph type="sldNum" sz="quarter" idx="10"/>
+          </p:nvPr>
+        </p:nvSpPr>
+        <p:spPr/>
+        <p:txBody>
+          <a:bodyPr/>
+          <a:lstStyle/>
+          <a:p>
+            <a:fld id="{F7021451-1387-4CA6-816F-3879F97B5CBC}" type="slidenum">
+              <a:rPr lang="en-US"/>
+              <a:t>14</a:t>
+            </a:fld>
+            <a:endParaRPr lang="en-US"/>
+          </a:p>
+        </p:txBody>
+      </p:sp>
+    </p:spTree>
+    <p:extLst>
+      <p:ext uri="{BB962C8B-B14F-4D97-AF65-F5344CB8AC3E}">
+        <p14:creationId xmlns:p14="http://schemas.microsoft.com/office/powerpoint/2010/main" val="1024086991"/>
+      </p:ext>
+    </p:extLst>
+  </p:cSld>
+  <p:clrMapOvr>
+    <a:masterClrMapping/>
+  </p:clrMapOvr>
+</p:notes>
+</file>
+
+<file path=ppt/notesSlides/notesSlide15.xml><?xml version="1.0" encoding="utf-8"?>
+<p:notes xmlns:a="http://schemas.openxmlformats.org/drawingml/2006/main" xmlns:r="http://schemas.openxmlformats.org/officeDocument/2006/relationships" xmlns:p="http://schemas.openxmlformats.org/presentationml/2006/main">
+  <p:cSld>
+    <p:spTree>
+      <p:nvGrpSpPr>
+        <p:cNvPr id="1" name=""/>
+        <p:cNvGrpSpPr/>
+        <p:nvPr/>
+      </p:nvGrpSpPr>
+      <p:grpSpPr>
+        <a:xfrm>
+          <a:off x="0" y="0"/>
+          <a:ext cx="0" cy="0"/>
+          <a:chOff x="0" y="0"/>
+          <a:chExt cx="0" cy="0"/>
+        </a:xfrm>
+      </p:grpSpPr>
+      <p:sp>
+        <p:nvSpPr>
+          <p:cNvPr id="2" name="Slide Image Placeholder 1"/>
+          <p:cNvSpPr>
+            <a:spLocks noGrp="1" noRot="1" noChangeAspect="1"/>
+          </p:cNvSpPr>
+          <p:nvPr>
+            <p:ph type="sldImg"/>
+          </p:nvPr>
+        </p:nvSpPr>
+        <p:spPr/>
+      </p:sp>
+      <p:sp>
+        <p:nvSpPr>
+          <p:cNvPr id="3" name="Notes Placeholder 2"/>
+          <p:cNvSpPr>
+            <a:spLocks noGrp="1"/>
+          </p:cNvSpPr>
+          <p:nvPr>
+            <p:ph type="body" idx="1"/>
+          </p:nvPr>
+        </p:nvSpPr>
+        <p:spPr/>
+        <p:txBody>
+          <a:bodyPr/>
+          <a:lstStyle/>
+          <a:p>
+            <a:r>
+              <a:rPr lang="en-US" dirty="0"/>
+              <a:t>Tested on copies of Inbar2 and Stav11 (end to end) and Stav1 (fallback), with the original iscell files checksummed before and after. Found along the way: the regular model computes some features differently at training and inference time.</a:t>
+            </a:r>
+            <a:endParaRPr lang="en-US" dirty="0"/>
+          </a:p>
+        </p:txBody>
+      </p:sp>
+      <p:sp>
+        <p:nvSpPr>
+          <p:cNvPr id="4" name="Slide Number Placeholder 3"/>
+          <p:cNvSpPr>
+            <a:spLocks noGrp="1"/>
+          </p:cNvSpPr>
+          <p:nvPr>
+            <p:ph type="sldNum" sz="quarter" idx="10"/>
+          </p:nvPr>
+        </p:nvSpPr>
+        <p:spPr/>
+        <p:txBody>
+          <a:bodyPr/>
+          <a:lstStyle/>
+          <a:p>
+            <a:fld id="{F7021451-1387-4CA6-816F-3879F97B5CBC}" type="slidenum">
+              <a:rPr lang="en-US"/>
+              <a:t>15</a:t>
+            </a:fld>
+            <a:endParaRPr lang="en-US"/>
+          </a:p>
+        </p:txBody>
+      </p:sp>
+    </p:spTree>
+    <p:extLst>
+      <p:ext uri="{BB962C8B-B14F-4D97-AF65-F5344CB8AC3E}">
+        <p14:creationId xmlns:p14="http://schemas.microsoft.com/office/powerpoint/2010/main" val="1024086991"/>
+      </p:ext>
+    </p:extLst>
+  </p:cSld>
+  <p:clrMapOvr>
+    <a:masterClrMapping/>
+  </p:clrMapOvr>
+</p:notes>
+</file>
+
+<file path=ppt/notesSlides/notesSlide16.xml><?xml version="1.0" encoding="utf-8"?>
+<p:notes xmlns:a="http://schemas.openxmlformats.org/drawingml/2006/main" xmlns:r="http://schemas.openxmlformats.org/officeDocument/2006/relationships" xmlns:p="http://schemas.openxmlformats.org/presentationml/2006/main">
+  <p:cSld>
+    <p:spTree>
+      <p:nvGrpSpPr>
+        <p:cNvPr id="1" name=""/>
+        <p:cNvGrpSpPr/>
+        <p:nvPr/>
+      </p:nvGrpSpPr>
+      <p:grpSpPr>
+        <a:xfrm>
+          <a:off x="0" y="0"/>
+          <a:ext cx="0" cy="0"/>
+          <a:chOff x="0" y="0"/>
+          <a:chExt cx="0" cy="0"/>
+        </a:xfrm>
+      </p:grpSpPr>
+      <p:sp>
+        <p:nvSpPr>
+          <p:cNvPr id="2" name="Slide Image Placeholder 1"/>
+          <p:cNvSpPr>
+            <a:spLocks noGrp="1" noRot="1" noChangeAspect="1"/>
+          </p:cNvSpPr>
+          <p:nvPr>
+            <p:ph type="sldImg"/>
+          </p:nvPr>
+        </p:nvSpPr>
+        <p:spPr/>
+      </p:sp>
+      <p:sp>
+        <p:nvSpPr>
+          <p:cNvPr id="3" name="Notes Placeholder 2"/>
+          <p:cNvSpPr>
+            <a:spLocks noGrp="1"/>
+          </p:cNvSpPr>
+          <p:nvPr>
+            <p:ph type="body" idx="1"/>
+          </p:nvPr>
+        </p:nvSpPr>
+        <p:spPr/>
+        <p:txBody>
+          <a:bodyPr/>
+          <a:lstStyle/>
+          <a:p>
+            <a:r>
+              <a:rPr lang="en-US" dirty="0"/>
+              <a:t>Code, results and this deck are on the branch feat/image-features in AddadyTom/suite2p-classification (results/REPORT.md and results/*.md for the full tables).</a:t>
+            </a:r>
+            <a:endParaRPr lang="en-US" dirty="0"/>
+          </a:p>
+        </p:txBody>
+      </p:sp>
+      <p:sp>
+        <p:nvSpPr>
+          <p:cNvPr id="4" name="Slide Number Placeholder 3"/>
+          <p:cNvSpPr>
+            <a:spLocks noGrp="1"/>
+          </p:cNvSpPr>
+          <p:nvPr>
+            <p:ph type="sldNum" sz="quarter" idx="10"/>
+          </p:nvPr>
+        </p:nvSpPr>
+        <p:spPr/>
+        <p:txBody>
+          <a:bodyPr/>
+          <a:lstStyle/>
+          <a:p>
+            <a:fld id="{F7021451-1387-4CA6-816F-3879F97B5CBC}" type="slidenum">
+              <a:rPr lang="en-US"/>
+              <a:t>16</a:t>
             </a:fld>
             <a:endParaRPr lang="en-US"/>
           </a:p>
@@ -5227,7 +5887,3281 @@
                 <a:ea typeface="Cambria" pitchFamily="34" charset="-122"/>
                 <a:cs typeface="Cambria" pitchFamily="34" charset="-120"/>
               </a:rPr>
-              <a:t>Hardest sessions: mostly labelling strictness</a:t>
+              <a:t>The labeller matters: own-lab training fits best</a:t>
+            </a:r>
+            <a:endParaRPr lang="en-US" sz="3000" dirty="0"/>
+          </a:p>
+        </p:txBody>
+      </p:sp>
+      <p:graphicFrame>
+        <p:nvGraphicFramePr>
+          <p:cNvPr id="3" name="own-lab advantage chart" descr=""/>
+          <p:cNvGraphicFramePr/>
+          <p:nvPr/>
+        </p:nvGraphicFramePr>
+        <p:xfrm>
+          <a:off x="548640" y="1234440"/>
+          <a:ext cx="6949440" cy="4983480"/>
+        </p:xfrm>
+        <a:graphic xmlns:a="http://schemas.openxmlformats.org/drawingml/2006/main">
+          <a:graphicData uri="http://schemas.openxmlformats.org/drawingml/2006/chart">
+            <c:chart xmlns:c="http://schemas.openxmlformats.org/drawingml/2006/chart" r:id="rId1"/>
+          </a:graphicData>
+        </a:graphic>
+      </p:graphicFrame>
+      <p:sp>
+        <p:nvSpPr>
+          <p:cNvPr id="4" name="labeller commentary card"/>
+          <p:cNvSpPr/>
+          <p:nvPr/>
+        </p:nvSpPr>
+        <p:spPr>
+          <a:xfrm>
+            <a:off x="7863840" y="1234440"/>
+            <a:ext cx="3779215" cy="4983480"/>
+          </a:xfrm>
+          <a:prstGeom prst="roundRect">
+            <a:avLst>
+              <a:gd name="adj" fmla="val 2903"/>
+            </a:avLst>
+          </a:prstGeom>
+          <a:solidFill>
+            <a:schemeClr val="bg2"/>
+          </a:solidFill>
+          <a:ln/>
+        </p:spPr>
+      </p:sp>
+      <p:sp>
+        <p:nvSpPr>
+          <p:cNvPr id="5" name="labeller commentary text"/>
+          <p:cNvSpPr txBox="1"/>
+          <p:nvPr/>
+        </p:nvSpPr>
+        <p:spPr>
+          <a:xfrm>
+            <a:off x="8138160" y="1417320"/>
+            <a:ext cx="3230575" cy="4617720"/>
+          </a:xfrm>
+          <a:prstGeom prst="rect">
+            <a:avLst/>
+          </a:prstGeom>
+          <a:noFill/>
+          <a:ln/>
+        </p:spPr>
+        <p:txBody>
+          <a:bodyPr wrap="square" lIns="0" tIns="0" rIns="0" bIns="0" rtlCol="0" anchor="t"/>
+          <a:lstStyle/>
+          <a:p>
+            <a:pPr indent="0" marL="0">
+              <a:spcAft>
+                <a:spcPts val="800"/>
+              </a:spcAft>
+              <a:buNone/>
+            </a:pPr>
+            <a:r>
+              <a:rPr lang="en-US" sz="1800" b="1" dirty="0">
+                <a:solidFill>
+                  <a:schemeClr val="tx2"/>
+                </a:solidFill>
+              </a:rPr>
+              <a:t>What we found</a:t>
+            </a:r>
+            <a:endParaRPr lang="en-US" sz="1800" dirty="0"/>
+          </a:p>
+          <a:p>
+            <a:pPr marL="342900" indent="-342900">
+              <a:spcAft>
+                <a:spcPts val="600"/>
+              </a:spcAft>
+              <a:buSzPct val="100000"/>
+              <a:buChar char="•"/>
+            </a:pPr>
+            <a:r>
+              <a:rPr lang="en-US" sz="1500" dirty="0">
+                <a:solidFill>
+                  <a:schemeClr val="tx1"/>
+                </a:solidFill>
+              </a:rPr>
+              <a:t>Stav's sessions: a Stav-trained model wins in 4 of 4 tests (+0.014 to +0.031)</a:t>
+            </a:r>
+            <a:endParaRPr lang="en-US" sz="1800" dirty="0"/>
+          </a:p>
+          <a:p>
+            <a:pPr marL="342900" indent="-342900">
+              <a:spcAft>
+                <a:spcPts val="600"/>
+              </a:spcAft>
+              <a:buSzPct val="100000"/>
+              <a:buChar char="•"/>
+            </a:pPr>
+            <a:r>
+              <a:rPr lang="en-US" sz="1500" dirty="0">
+                <a:solidFill>
+                  <a:schemeClr val="tx1"/>
+                </a:solidFill>
+              </a:rPr>
+              <a:t>Inbar's sessions: an Inbar-trained model wins clearly on the hardest ones (+0.041)</a:t>
+            </a:r>
+            <a:endParaRPr lang="en-US" sz="1800" dirty="0"/>
+          </a:p>
+          <a:p>
+            <a:pPr marL="342900" indent="-342900">
+              <a:buSzPct val="100000"/>
+              <a:buChar char="•"/>
+            </a:pPr>
+            <a:r>
+              <a:rPr lang="en-US" sz="1500" dirty="0">
+                <a:solidFill>
+                  <a:schemeClr val="tx1"/>
+                </a:solidFill>
+              </a:rPr>
+              <a:t>On typical Inbar sessions it only ties, with half the training data (8 sessions vs 17)</a:t>
+            </a:r>
+            <a:endParaRPr lang="en-US" sz="1800" dirty="0"/>
+          </a:p>
+        </p:txBody>
+      </p:sp>
+      <p:sp>
+        <p:nvSpPr>
+          <p:cNvPr id="25" name="Slide Number Placeholder 0"/>
+          <p:cNvSpPr>
+            <a:spLocks noGrp="1"/>
+          </p:cNvSpPr>
+          <p:nvPr>
+            <p:ph type="sldNum" sz="quarter" idx="4294967295"/>
+          </p:nvPr>
+        </p:nvSpPr>
+        <p:spPr>
+          <a:xfrm>
+            <a:off x="11185855" y="6400800"/>
+            <a:ext cx="457200" cy="274320"/>
+          </a:xfrm>
+          <a:prstGeom prst="rect">
+            <a:avLst/>
+          </a:prstGeom>
+          <a:extLst>
+            <a:ext uri="{C572A759-6A51-4108-AA02-DFA0A04FC94B}">
+              <ma14:wrappingTextBoxFlag xmlns:ma14="http://schemas.microsoft.com/office/mac/drawingml/2011/main" val="0"/>
+            </a:ext>
+          </a:extLst>
+        </p:spPr>
+        <p:txBody>
+          <a:bodyPr/>
+          <a:lstStyle>
+            <a:lvl1pPr>
+              <a:defRPr sz="1000">
+                <a:solidFill>
+                  <a:schemeClr val="accent4"/>
+                </a:solidFill>
+              </a:defRPr>
+            </a:lvl1pPr>
+          </a:lstStyle>
+          <a:p>
+            <a:pPr algn="r"/>
+            <a:fld id="{F7021451-1387-4CA6-816F-3879F97B5CBC}" type="slidenum">
+              <a:rPr b="0" lang="en-US"/>
+              <a:t>11</a:t>
+            </a:fld>
+            <a:endParaRPr lang="en-US"/>
+          </a:p>
+        </p:txBody>
+      </p:sp>
+    </p:spTree>
+  </p:cSld>
+  <p:clrMapOvr>
+    <a:masterClrMapping/>
+  </p:clrMapOvr>
+</p:sld>
+</file>
+
+<file path=ppt/slides/slide12.xml><?xml version="1.0" encoding="utf-8"?>
+<p:sld xmlns:a="http://schemas.openxmlformats.org/drawingml/2006/main" xmlns:r="http://schemas.openxmlformats.org/officeDocument/2006/relationships" xmlns:p="http://schemas.openxmlformats.org/presentationml/2006/main">
+  <p:cSld name="Slide 12">
+    <p:spTree>
+      <p:nvGrpSpPr>
+        <p:cNvPr id="1" name=""/>
+        <p:cNvGrpSpPr/>
+        <p:nvPr/>
+      </p:nvGrpSpPr>
+      <p:grpSpPr>
+        <a:xfrm>
+          <a:off x="0" y="0"/>
+          <a:ext cx="0" cy="0"/>
+          <a:chOff x="0" y="0"/>
+          <a:chExt cx="0" cy="0"/>
+        </a:xfrm>
+      </p:grpSpPr>
+      <p:sp>
+        <p:nvSpPr>
+          <p:cNvPr id="2" name="Text 0"/>
+          <p:cNvSpPr/>
+          <p:nvPr>
+            <p:ph idx="100" type="title" hasCustomPrompt="1"/>
+          </p:nvPr>
+        </p:nvSpPr>
+        <p:spPr>
+          <a:xfrm>
+            <a:off x="548640" y="320040"/>
+            <a:ext cx="11094415" cy="777240"/>
+          </a:xfrm>
+          <a:prstGeom prst="rect">
+            <a:avLst/>
+          </a:prstGeom>
+          <a:noFill/>
+          <a:ln/>
+        </p:spPr>
+        <p:txBody>
+          <a:bodyPr wrap="square" lIns="0" tIns="0" rIns="0" bIns="0" rtlCol="0" anchor="ctr"/>
+          <a:lstStyle/>
+          <a:p>
+            <a:pPr indent="0" marL="0">
+              <a:buNone/>
+            </a:pPr>
+            <a:r>
+              <a:rPr lang="en-US" sz="3000" b="1" dirty="0">
+                <a:solidFill>
+                  <a:schemeClr val="tx2"/>
+                </a:solidFill>
+                <a:latin typeface="Cambria" pitchFamily="34" charset="0"/>
+                <a:ea typeface="Cambria" pitchFamily="34" charset="-122"/>
+                <a:cs typeface="Cambria" pitchFamily="34" charset="-120"/>
+              </a:rPr>
+              <a:t>How we tested it: train on one lab, test on another</a:t>
+            </a:r>
+            <a:endParaRPr lang="en-US" sz="3000" dirty="0"/>
+          </a:p>
+        </p:txBody>
+      </p:sp>
+      <p:sp>
+        <p:nvSpPr>
+          <p:cNvPr id="3" name="experiment 1 card"/>
+          <p:cNvSpPr/>
+          <p:nvPr/>
+        </p:nvSpPr>
+        <p:spPr>
+          <a:xfrm>
+            <a:off x="548640" y="1325880"/>
+            <a:ext cx="3515258" cy="3017520"/>
+          </a:xfrm>
+          <a:prstGeom prst="roundRect">
+            <a:avLst>
+              <a:gd name="adj" fmla="val 3636"/>
+            </a:avLst>
+          </a:prstGeom>
+          <a:solidFill>
+            <a:schemeClr val="bg2"/>
+          </a:solidFill>
+          <a:ln/>
+        </p:spPr>
+      </p:sp>
+      <p:sp>
+        <p:nvSpPr>
+          <p:cNvPr id="4" name="experiment 1 dot"/>
+          <p:cNvSpPr/>
+          <p:nvPr/>
+        </p:nvSpPr>
+        <p:spPr>
+          <a:xfrm>
+            <a:off x="822960" y="1554480"/>
+            <a:ext cx="502920" cy="502920"/>
+          </a:xfrm>
+          <a:prstGeom prst="ellipse">
+            <a:avLst/>
+          </a:prstGeom>
+          <a:solidFill>
+            <a:schemeClr val="accent2"/>
+          </a:solidFill>
+          <a:ln/>
+        </p:spPr>
+      </p:sp>
+      <p:sp>
+        <p:nvSpPr>
+          <p:cNvPr id="5" name="experiment 1 num"/>
+          <p:cNvSpPr txBox="1"/>
+          <p:nvPr/>
+        </p:nvSpPr>
+        <p:spPr>
+          <a:xfrm>
+            <a:off x="822960" y="1554480"/>
+            <a:ext cx="502920" cy="502920"/>
+          </a:xfrm>
+          <a:prstGeom prst="rect">
+            <a:avLst/>
+          </a:prstGeom>
+          <a:noFill/>
+          <a:ln/>
+        </p:spPr>
+        <p:txBody>
+          <a:bodyPr wrap="square" lIns="0" tIns="0" rIns="0" bIns="0" rtlCol="0" anchor="ctr"/>
+          <a:lstStyle/>
+          <a:p>
+            <a:pPr algn="ctr" indent="0" marL="0">
+              <a:buNone/>
+            </a:pPr>
+            <a:r>
+              <a:rPr lang="en-US" sz="1700" b="1" dirty="0">
+                <a:solidFill>
+                  <a:schemeClr val="bg1"/>
+                </a:solidFill>
+              </a:rPr>
+              <a:t>1</a:t>
+            </a:r>
+            <a:endParaRPr lang="en-US" sz="1700" dirty="0"/>
+          </a:p>
+        </p:txBody>
+      </p:sp>
+      <p:sp>
+        <p:nvSpPr>
+          <p:cNvPr id="6" name="experiment 1 text"/>
+          <p:cNvSpPr txBox="1"/>
+          <p:nvPr/>
+        </p:nvSpPr>
+        <p:spPr>
+          <a:xfrm>
+            <a:off x="822960" y="2240280"/>
+            <a:ext cx="2966618" cy="2011680"/>
+          </a:xfrm>
+          <a:prstGeom prst="rect">
+            <a:avLst/>
+          </a:prstGeom>
+          <a:noFill/>
+          <a:ln/>
+        </p:spPr>
+        <p:txBody>
+          <a:bodyPr wrap="square" lIns="0" tIns="0" rIns="0" bIns="0" rtlCol="0" anchor="t"/>
+          <a:lstStyle/>
+          <a:p>
+            <a:pPr indent="0" marL="0">
+              <a:spcAft>
+                <a:spcPts val="600"/>
+              </a:spcAft>
+              <a:buNone/>
+            </a:pPr>
+            <a:r>
+              <a:rPr lang="en-US" sz="1700" b="1" dirty="0">
+                <a:solidFill>
+                  <a:schemeClr val="tx2"/>
+                </a:solidFill>
+              </a:rPr>
+              <a:t>Hardest sessions, both labs</a:t>
+            </a:r>
+            <a:endParaRPr lang="en-US" sz="1700" dirty="0"/>
+          </a:p>
+          <a:p>
+            <a:pPr indent="0" marL="0">
+              <a:buNone/>
+            </a:pPr>
+            <a:r>
+              <a:rPr lang="en-US" sz="1500" dirty="0">
+                <a:solidFill>
+                  <a:schemeClr val="tx1"/>
+                </a:solidFill>
+              </a:rPr>
+              <a:t>Hold out the 4 lowest-scoring sessions of one lab. Train on: that lab only, the other lab only, both, and both with labs weighted equally.</a:t>
+            </a:r>
+            <a:endParaRPr lang="en-US" sz="1700" dirty="0"/>
+          </a:p>
+        </p:txBody>
+      </p:sp>
+      <p:sp>
+        <p:nvSpPr>
+          <p:cNvPr id="7" name="experiment 2 card"/>
+          <p:cNvSpPr/>
+          <p:nvPr/>
+        </p:nvSpPr>
+        <p:spPr>
+          <a:xfrm>
+            <a:off x="4338218" y="1325880"/>
+            <a:ext cx="3515258" cy="3017520"/>
+          </a:xfrm>
+          <a:prstGeom prst="roundRect">
+            <a:avLst>
+              <a:gd name="adj" fmla="val 3636"/>
+            </a:avLst>
+          </a:prstGeom>
+          <a:solidFill>
+            <a:schemeClr val="bg2"/>
+          </a:solidFill>
+          <a:ln/>
+        </p:spPr>
+      </p:sp>
+      <p:sp>
+        <p:nvSpPr>
+          <p:cNvPr id="8" name="experiment 2 dot"/>
+          <p:cNvSpPr/>
+          <p:nvPr/>
+        </p:nvSpPr>
+        <p:spPr>
+          <a:xfrm>
+            <a:off x="4612538" y="1554480"/>
+            <a:ext cx="502920" cy="502920"/>
+          </a:xfrm>
+          <a:prstGeom prst="ellipse">
+            <a:avLst/>
+          </a:prstGeom>
+          <a:solidFill>
+            <a:schemeClr val="accent2"/>
+          </a:solidFill>
+          <a:ln/>
+        </p:spPr>
+      </p:sp>
+      <p:sp>
+        <p:nvSpPr>
+          <p:cNvPr id="9" name="experiment 2 num"/>
+          <p:cNvSpPr txBox="1"/>
+          <p:nvPr/>
+        </p:nvSpPr>
+        <p:spPr>
+          <a:xfrm>
+            <a:off x="4612538" y="1554480"/>
+            <a:ext cx="502920" cy="502920"/>
+          </a:xfrm>
+          <a:prstGeom prst="rect">
+            <a:avLst/>
+          </a:prstGeom>
+          <a:noFill/>
+          <a:ln/>
+        </p:spPr>
+        <p:txBody>
+          <a:bodyPr wrap="square" lIns="0" tIns="0" rIns="0" bIns="0" rtlCol="0" anchor="ctr"/>
+          <a:lstStyle/>
+          <a:p>
+            <a:pPr algn="ctr" indent="0" marL="0">
+              <a:buNone/>
+            </a:pPr>
+            <a:r>
+              <a:rPr lang="en-US" sz="1700" b="1" dirty="0">
+                <a:solidFill>
+                  <a:schemeClr val="bg1"/>
+                </a:solidFill>
+              </a:rPr>
+              <a:t>2</a:t>
+            </a:r>
+            <a:endParaRPr lang="en-US" sz="1700" dirty="0"/>
+          </a:p>
+        </p:txBody>
+      </p:sp>
+      <p:sp>
+        <p:nvSpPr>
+          <p:cNvPr id="10" name="experiment 2 text"/>
+          <p:cNvSpPr txBox="1"/>
+          <p:nvPr/>
+        </p:nvSpPr>
+        <p:spPr>
+          <a:xfrm>
+            <a:off x="4612538" y="2240280"/>
+            <a:ext cx="2966618" cy="2011680"/>
+          </a:xfrm>
+          <a:prstGeom prst="rect">
+            <a:avLst/>
+          </a:prstGeom>
+          <a:noFill/>
+          <a:ln/>
+        </p:spPr>
+        <p:txBody>
+          <a:bodyPr wrap="square" lIns="0" tIns="0" rIns="0" bIns="0" rtlCol="0" anchor="t"/>
+          <a:lstStyle/>
+          <a:p>
+            <a:pPr indent="0" marL="0">
+              <a:spcAft>
+                <a:spcPts val="600"/>
+              </a:spcAft>
+              <a:buNone/>
+            </a:pPr>
+            <a:r>
+              <a:rPr lang="en-US" sz="1700" b="1" dirty="0">
+                <a:solidFill>
+                  <a:schemeClr val="tx2"/>
+                </a:solidFill>
+              </a:rPr>
+              <a:t>Random sessions, both labs</a:t>
+            </a:r>
+            <a:endParaRPr lang="en-US" sz="1700" dirty="0"/>
+          </a:p>
+          <a:p>
+            <a:pPr indent="0" marL="0">
+              <a:buNone/>
+            </a:pPr>
+            <a:r>
+              <a:rPr lang="en-US" sz="1500" dirty="0">
+                <a:solidFill>
+                  <a:schemeClr val="tx1"/>
+                </a:solidFill>
+              </a:rPr>
+              <a:t>Repeat with 3 random draws of 4 held-out sessions per lab, so the result can't come from picking hard sessions.</a:t>
+            </a:r>
+            <a:endParaRPr lang="en-US" sz="1700" dirty="0"/>
+          </a:p>
+        </p:txBody>
+      </p:sp>
+      <p:sp>
+        <p:nvSpPr>
+          <p:cNvPr id="11" name="experiment 3 card"/>
+          <p:cNvSpPr/>
+          <p:nvPr/>
+        </p:nvSpPr>
+        <p:spPr>
+          <a:xfrm>
+            <a:off x="8127797" y="1325880"/>
+            <a:ext cx="3515258" cy="3017520"/>
+          </a:xfrm>
+          <a:prstGeom prst="roundRect">
+            <a:avLst>
+              <a:gd name="adj" fmla="val 3636"/>
+            </a:avLst>
+          </a:prstGeom>
+          <a:solidFill>
+            <a:schemeClr val="bg2"/>
+          </a:solidFill>
+          <a:ln/>
+        </p:spPr>
+      </p:sp>
+      <p:sp>
+        <p:nvSpPr>
+          <p:cNvPr id="12" name="experiment 3 dot"/>
+          <p:cNvSpPr/>
+          <p:nvPr/>
+        </p:nvSpPr>
+        <p:spPr>
+          <a:xfrm>
+            <a:off x="8402117" y="1554480"/>
+            <a:ext cx="502920" cy="502920"/>
+          </a:xfrm>
+          <a:prstGeom prst="ellipse">
+            <a:avLst/>
+          </a:prstGeom>
+          <a:solidFill>
+            <a:schemeClr val="accent2"/>
+          </a:solidFill>
+          <a:ln/>
+        </p:spPr>
+      </p:sp>
+      <p:sp>
+        <p:nvSpPr>
+          <p:cNvPr id="13" name="experiment 3 num"/>
+          <p:cNvSpPr txBox="1"/>
+          <p:nvPr/>
+        </p:nvSpPr>
+        <p:spPr>
+          <a:xfrm>
+            <a:off x="8402117" y="1554480"/>
+            <a:ext cx="502920" cy="502920"/>
+          </a:xfrm>
+          <a:prstGeom prst="rect">
+            <a:avLst/>
+          </a:prstGeom>
+          <a:noFill/>
+          <a:ln/>
+        </p:spPr>
+        <p:txBody>
+          <a:bodyPr wrap="square" lIns="0" tIns="0" rIns="0" bIns="0" rtlCol="0" anchor="ctr"/>
+          <a:lstStyle/>
+          <a:p>
+            <a:pPr algn="ctr" indent="0" marL="0">
+              <a:buNone/>
+            </a:pPr>
+            <a:r>
+              <a:rPr lang="en-US" sz="1700" b="1" dirty="0">
+                <a:solidFill>
+                  <a:schemeClr val="bg1"/>
+                </a:solidFill>
+              </a:rPr>
+              <a:t>3</a:t>
+            </a:r>
+            <a:endParaRPr lang="en-US" sz="1700" dirty="0"/>
+          </a:p>
+        </p:txBody>
+      </p:sp>
+      <p:sp>
+        <p:nvSpPr>
+          <p:cNvPr id="14" name="experiment 3 text"/>
+          <p:cNvSpPr txBox="1"/>
+          <p:nvPr/>
+        </p:nvSpPr>
+        <p:spPr>
+          <a:xfrm>
+            <a:off x="8402117" y="2240280"/>
+            <a:ext cx="2966618" cy="2011680"/>
+          </a:xfrm>
+          <a:prstGeom prst="rect">
+            <a:avLst/>
+          </a:prstGeom>
+          <a:noFill/>
+          <a:ln/>
+        </p:spPr>
+        <p:txBody>
+          <a:bodyPr wrap="square" lIns="0" tIns="0" rIns="0" bIns="0" rtlCol="0" anchor="t"/>
+          <a:lstStyle/>
+          <a:p>
+            <a:pPr indent="0" marL="0">
+              <a:spcAft>
+                <a:spcPts val="600"/>
+              </a:spcAft>
+              <a:buNone/>
+            </a:pPr>
+            <a:r>
+              <a:rPr lang="en-US" sz="1700" b="1" dirty="0">
+                <a:solidFill>
+                  <a:schemeClr val="tx2"/>
+                </a:solidFill>
+              </a:rPr>
+              <a:t>Threshold and label rate</a:t>
+            </a:r>
+            <a:endParaRPr lang="en-US" sz="1700" dirty="0"/>
+          </a:p>
+          <a:p>
+            <a:pPr indent="0" marL="0">
+              <a:buNone/>
+            </a:pPr>
+            <a:r>
+              <a:rPr lang="en-US" sz="1500" dirty="0">
+                <a:solidFill>
+                  <a:schemeClr val="tx1"/>
+                </a:solidFill>
+              </a:rPr>
+              <a:t>For each held-out session, compare F1 at the trained threshold with F1 at that session's own best threshold, and predicted vs labelled cell rate.</a:t>
+            </a:r>
+            <a:endParaRPr lang="en-US" sz="1700" dirty="0"/>
+          </a:p>
+        </p:txBody>
+      </p:sp>
+      <p:sp>
+        <p:nvSpPr>
+          <p:cNvPr id="15" name="rules card"/>
+          <p:cNvSpPr/>
+          <p:nvPr/>
+        </p:nvSpPr>
+        <p:spPr>
+          <a:xfrm>
+            <a:off x="548640" y="4617720"/>
+            <a:ext cx="11094415" cy="1508760"/>
+          </a:xfrm>
+          <a:prstGeom prst="roundRect">
+            <a:avLst>
+              <a:gd name="adj" fmla="val 7273"/>
+            </a:avLst>
+          </a:prstGeom>
+          <a:solidFill>
+            <a:schemeClr val="bg2"/>
+          </a:solidFill>
+          <a:ln/>
+        </p:spPr>
+      </p:sp>
+      <p:sp>
+        <p:nvSpPr>
+          <p:cNvPr id="16" name="rules text"/>
+          <p:cNvSpPr txBox="1"/>
+          <p:nvPr/>
+        </p:nvSpPr>
+        <p:spPr>
+          <a:xfrm>
+            <a:off x="822960" y="4754880"/>
+            <a:ext cx="10545775" cy="1280160"/>
+          </a:xfrm>
+          <a:prstGeom prst="rect">
+            <a:avLst/>
+          </a:prstGeom>
+          <a:noFill/>
+          <a:ln/>
+        </p:spPr>
+        <p:txBody>
+          <a:bodyPr wrap="square" lIns="0" tIns="0" rIns="0" bIns="0" rtlCol="0" anchor="t"/>
+          <a:lstStyle/>
+          <a:p>
+            <a:pPr indent="0" marL="0">
+              <a:spcAft>
+                <a:spcPts val="400"/>
+              </a:spcAft>
+              <a:buNone/>
+            </a:pPr>
+            <a:r>
+              <a:rPr lang="en-US" sz="1600" b="1" dirty="0">
+                <a:solidFill>
+                  <a:schemeClr val="tx2"/>
+                </a:solidFill>
+              </a:rPr>
+              <a:t>Kept fixed in every experiment</a:t>
+            </a:r>
+            <a:endParaRPr lang="en-US" sz="1600" dirty="0"/>
+          </a:p>
+          <a:p>
+            <a:pPr marL="342900" indent="-342900">
+              <a:buSzPct val="100000"/>
+              <a:buChar char="•"/>
+            </a:pPr>
+            <a:r>
+              <a:rPr lang="en-US" sz="1500" dirty="0">
+                <a:solidFill>
+                  <a:schemeClr val="tx1"/>
+                </a:solidFill>
+              </a:rPr>
+              <a:t>Same 44 features and LightGBM settings as the shipped model</a:t>
+            </a:r>
+            <a:endParaRPr lang="en-US" sz="1600" dirty="0"/>
+          </a:p>
+          <a:p>
+            <a:pPr marL="342900" indent="-342900">
+              <a:buSzPct val="100000"/>
+              <a:buChar char="•"/>
+            </a:pPr>
+            <a:r>
+              <a:rPr lang="en-US" sz="1500" dirty="0">
+                <a:solidFill>
+                  <a:schemeClr val="tx1"/>
+                </a:solidFill>
+              </a:rPr>
+              <a:t>Threshold and number of trees chosen on the training sessions only; test sessions are never seen in training</a:t>
+            </a:r>
+            <a:endParaRPr lang="en-US" sz="1600" dirty="0"/>
+          </a:p>
+        </p:txBody>
+      </p:sp>
+      <p:sp>
+        <p:nvSpPr>
+          <p:cNvPr id="25" name="Slide Number Placeholder 0"/>
+          <p:cNvSpPr>
+            <a:spLocks noGrp="1"/>
+          </p:cNvSpPr>
+          <p:nvPr>
+            <p:ph type="sldNum" sz="quarter" idx="4294967295"/>
+          </p:nvPr>
+        </p:nvSpPr>
+        <p:spPr>
+          <a:xfrm>
+            <a:off x="11185855" y="6400800"/>
+            <a:ext cx="457200" cy="274320"/>
+          </a:xfrm>
+          <a:prstGeom prst="rect">
+            <a:avLst/>
+          </a:prstGeom>
+          <a:extLst>
+            <a:ext uri="{C572A759-6A51-4108-AA02-DFA0A04FC94B}">
+              <ma14:wrappingTextBoxFlag xmlns:ma14="http://schemas.microsoft.com/office/mac/drawingml/2011/main" val="0"/>
+            </a:ext>
+          </a:extLst>
+        </p:spPr>
+        <p:txBody>
+          <a:bodyPr/>
+          <a:lstStyle>
+            <a:lvl1pPr>
+              <a:defRPr sz="1000">
+                <a:solidFill>
+                  <a:schemeClr val="accent4"/>
+                </a:solidFill>
+              </a:defRPr>
+            </a:lvl1pPr>
+          </a:lstStyle>
+          <a:p>
+            <a:pPr algn="r"/>
+            <a:fld id="{F7021451-1387-4CA6-816F-3879F97B5CBC}" type="slidenum">
+              <a:rPr b="0" lang="en-US"/>
+              <a:t>12</a:t>
+            </a:fld>
+            <a:endParaRPr lang="en-US"/>
+          </a:p>
+        </p:txBody>
+      </p:sp>
+    </p:spTree>
+  </p:cSld>
+  <p:clrMapOvr>
+    <a:masterClrMapping/>
+  </p:clrMapOvr>
+</p:sld>
+</file>
+
+<file path=ppt/slides/slide13.xml><?xml version="1.0" encoding="utf-8"?>
+<p:sld xmlns:a="http://schemas.openxmlformats.org/drawingml/2006/main" xmlns:r="http://schemas.openxmlformats.org/officeDocument/2006/relationships" xmlns:p="http://schemas.openxmlformats.org/presentationml/2006/main">
+  <p:cSld name="Slide 13">
+    <p:spTree>
+      <p:nvGrpSpPr>
+        <p:cNvPr id="1" name=""/>
+        <p:cNvGrpSpPr/>
+        <p:nvPr/>
+      </p:nvGrpSpPr>
+      <p:grpSpPr>
+        <a:xfrm>
+          <a:off x="0" y="0"/>
+          <a:ext cx="0" cy="0"/>
+          <a:chOff x="0" y="0"/>
+          <a:chExt cx="0" cy="0"/>
+        </a:xfrm>
+      </p:grpSpPr>
+      <p:sp>
+        <p:nvSpPr>
+          <p:cNvPr id="2" name="Text 0"/>
+          <p:cNvSpPr/>
+          <p:nvPr>
+            <p:ph idx="100" type="title" hasCustomPrompt="1"/>
+          </p:nvPr>
+        </p:nvSpPr>
+        <p:spPr>
+          <a:xfrm>
+            <a:off x="548640" y="320040"/>
+            <a:ext cx="11094415" cy="777240"/>
+          </a:xfrm>
+          <a:prstGeom prst="rect">
+            <a:avLst/>
+          </a:prstGeom>
+          <a:noFill/>
+          <a:ln/>
+        </p:spPr>
+        <p:txBody>
+          <a:bodyPr wrap="square" lIns="0" tIns="0" rIns="0" bIns="0" rtlCol="0" anchor="ctr"/>
+          <a:lstStyle/>
+          <a:p>
+            <a:pPr indent="0" marL="0">
+              <a:buNone/>
+            </a:pPr>
+            <a:r>
+              <a:rPr lang="en-US" sz="3000" b="1" dirty="0">
+                <a:solidFill>
+                  <a:schemeClr val="tx2"/>
+                </a:solidFill>
+                <a:latin typeface="Cambria" pitchFamily="34" charset="0"/>
+                <a:ea typeface="Cambria" pitchFamily="34" charset="-122"/>
+                <a:cs typeface="Cambria" pitchFamily="34" charset="-120"/>
+              </a:rPr>
+              <a:t>All eight experiments, F1 on the held-out sessions</a:t>
+            </a:r>
+            <a:endParaRPr lang="en-US" sz="3000" dirty="0"/>
+          </a:p>
+        </p:txBody>
+      </p:sp>
+      <p:graphicFrame>
+        <p:nvGraphicFramePr>
+          <p:cNvPr id="14" name="labeller results table"/>
+          <p:cNvGraphicFramePr>
+            <a:graphicFrameLocks noGrp="1"/>
+          </p:cNvGraphicFramePr>
+          <p:nvPr>
+            <p:extLst>
+              <p:ext uri="{D42A27DB-BD31-4B8C-83A1-F6EECF244321}">
+                <p14:modId xmlns:p14="http://schemas.microsoft.com/office/powerpoint/2010/main" val="1579011935"/>
+              </p:ext>
+            </p:extLst>
+          </p:nvPr>
+        </p:nvGraphicFramePr>
+        <p:xfrm>
+          <a:off x="548640" y="1280160"/>
+          <a:ext cx="11094415" cy="914400"/>
+        </p:xfrm>
+        <a:graphic>
+          <a:graphicData uri="http://schemas.openxmlformats.org/drawingml/2006/table">
+            <a:tbl>
+              <a:tblPr/>
+              <a:tblGrid>
+                <a:gridCol w="4770599"/>
+                <a:gridCol w="2107939"/>
+                <a:gridCol w="2107939"/>
+                <a:gridCol w="2107939"/>
+              </a:tblGrid>
+              <a:tr h="384048">
+                <a:tc>
+                  <a:txBody>
+                    <a:bodyPr/>
+                    <a:lstStyle/>
+                    <a:p>
+                      <a:pPr indent="0" marL="0">
+                        <a:buNone/>
+                      </a:pPr>
+                      <a:r>
+                        <a:rPr lang="en-US" sz="1400" b="1" dirty="0">
+                          <a:solidFill>
+                            <a:schemeClr val="bg1"/>
+                          </a:solidFill>
+                        </a:rPr>
+                        <a:t>Held-out sessions</a:t>
+                      </a:r>
+                      <a:endParaRPr lang="en-US" sz="1400" dirty="0"/>
+                    </a:p>
+                  </a:txBody>
+                  <a:tcPr marL="91440" marR="91440" marT="45720" marB="45720">
+                    <a:lnL w="6350" cap="flat" cmpd="sng" algn="ctr">
+                      <a:solidFill>
+                        <a:srgbClr val="DDE5E4"/>
+                      </a:solidFill>
+                      <a:prstDash val="solid"/>
+                      <a:round/>
+                      <a:headEnd type="none" w="med" len="med"/>
+                      <a:tailEnd type="none" w="med" len="med"/>
+                    </a:lnL>
+                    <a:lnR w="6350" cap="flat" cmpd="sng" algn="ctr">
+                      <a:solidFill>
+                        <a:srgbClr val="DDE5E4"/>
+                      </a:solidFill>
+                      <a:prstDash val="solid"/>
+                      <a:round/>
+                      <a:headEnd type="none" w="med" len="med"/>
+                      <a:tailEnd type="none" w="med" len="med"/>
+                    </a:lnR>
+                    <a:lnT w="6350" cap="flat" cmpd="sng" algn="ctr">
+                      <a:solidFill>
+                        <a:srgbClr val="DDE5E4"/>
+                      </a:solidFill>
+                      <a:prstDash val="solid"/>
+                      <a:round/>
+                      <a:headEnd type="none" w="med" len="med"/>
+                      <a:tailEnd type="none" w="med" len="med"/>
+                    </a:lnT>
+                    <a:lnB w="6350" cap="flat" cmpd="sng" algn="ctr">
+                      <a:solidFill>
+                        <a:srgbClr val="DDE5E4"/>
+                      </a:solidFill>
+                      <a:prstDash val="solid"/>
+                      <a:round/>
+                      <a:headEnd type="none" w="med" len="med"/>
+                      <a:tailEnd type="none" w="med" len="med"/>
+                    </a:lnB>
+                    <a:solidFill>
+                      <a:schemeClr val="tx2"/>
+                    </a:solidFill>
+                  </a:tcPr>
+                </a:tc>
+                <a:tc>
+                  <a:txBody>
+                    <a:bodyPr/>
+                    <a:lstStyle/>
+                    <a:p>
+                      <a:pPr indent="0" marL="0">
+                        <a:buNone/>
+                      </a:pPr>
+                      <a:r>
+                        <a:rPr lang="en-US" sz="1400" b="1" dirty="0">
+                          <a:solidFill>
+                            <a:schemeClr val="bg1"/>
+                          </a:solidFill>
+                        </a:rPr>
+                        <a:t>Trained on Stav</a:t>
+                      </a:r>
+                      <a:endParaRPr lang="en-US" sz="1400" dirty="0"/>
+                    </a:p>
+                  </a:txBody>
+                  <a:tcPr marL="91440" marR="91440" marT="45720" marB="45720">
+                    <a:lnL w="6350" cap="flat" cmpd="sng" algn="ctr">
+                      <a:solidFill>
+                        <a:srgbClr val="DDE5E4"/>
+                      </a:solidFill>
+                      <a:prstDash val="solid"/>
+                      <a:round/>
+                      <a:headEnd type="none" w="med" len="med"/>
+                      <a:tailEnd type="none" w="med" len="med"/>
+                    </a:lnL>
+                    <a:lnR w="6350" cap="flat" cmpd="sng" algn="ctr">
+                      <a:solidFill>
+                        <a:srgbClr val="DDE5E4"/>
+                      </a:solidFill>
+                      <a:prstDash val="solid"/>
+                      <a:round/>
+                      <a:headEnd type="none" w="med" len="med"/>
+                      <a:tailEnd type="none" w="med" len="med"/>
+                    </a:lnR>
+                    <a:lnT w="6350" cap="flat" cmpd="sng" algn="ctr">
+                      <a:solidFill>
+                        <a:srgbClr val="DDE5E4"/>
+                      </a:solidFill>
+                      <a:prstDash val="solid"/>
+                      <a:round/>
+                      <a:headEnd type="none" w="med" len="med"/>
+                      <a:tailEnd type="none" w="med" len="med"/>
+                    </a:lnT>
+                    <a:lnB w="6350" cap="flat" cmpd="sng" algn="ctr">
+                      <a:solidFill>
+                        <a:srgbClr val="DDE5E4"/>
+                      </a:solidFill>
+                      <a:prstDash val="solid"/>
+                      <a:round/>
+                      <a:headEnd type="none" w="med" len="med"/>
+                      <a:tailEnd type="none" w="med" len="med"/>
+                    </a:lnB>
+                    <a:solidFill>
+                      <a:schemeClr val="tx2"/>
+                    </a:solidFill>
+                  </a:tcPr>
+                </a:tc>
+                <a:tc>
+                  <a:txBody>
+                    <a:bodyPr/>
+                    <a:lstStyle/>
+                    <a:p>
+                      <a:pPr indent="0" marL="0">
+                        <a:buNone/>
+                      </a:pPr>
+                      <a:r>
+                        <a:rPr lang="en-US" sz="1400" b="1" dirty="0">
+                          <a:solidFill>
+                            <a:schemeClr val="bg1"/>
+                          </a:solidFill>
+                        </a:rPr>
+                        <a:t>Trained on Inbar</a:t>
+                      </a:r>
+                      <a:endParaRPr lang="en-US" sz="1400" dirty="0"/>
+                    </a:p>
+                  </a:txBody>
+                  <a:tcPr marL="91440" marR="91440" marT="45720" marB="45720">
+                    <a:lnL w="6350" cap="flat" cmpd="sng" algn="ctr">
+                      <a:solidFill>
+                        <a:srgbClr val="DDE5E4"/>
+                      </a:solidFill>
+                      <a:prstDash val="solid"/>
+                      <a:round/>
+                      <a:headEnd type="none" w="med" len="med"/>
+                      <a:tailEnd type="none" w="med" len="med"/>
+                    </a:lnL>
+                    <a:lnR w="6350" cap="flat" cmpd="sng" algn="ctr">
+                      <a:solidFill>
+                        <a:srgbClr val="DDE5E4"/>
+                      </a:solidFill>
+                      <a:prstDash val="solid"/>
+                      <a:round/>
+                      <a:headEnd type="none" w="med" len="med"/>
+                      <a:tailEnd type="none" w="med" len="med"/>
+                    </a:lnR>
+                    <a:lnT w="6350" cap="flat" cmpd="sng" algn="ctr">
+                      <a:solidFill>
+                        <a:srgbClr val="DDE5E4"/>
+                      </a:solidFill>
+                      <a:prstDash val="solid"/>
+                      <a:round/>
+                      <a:headEnd type="none" w="med" len="med"/>
+                      <a:tailEnd type="none" w="med" len="med"/>
+                    </a:lnT>
+                    <a:lnB w="6350" cap="flat" cmpd="sng" algn="ctr">
+                      <a:solidFill>
+                        <a:srgbClr val="DDE5E4"/>
+                      </a:solidFill>
+                      <a:prstDash val="solid"/>
+                      <a:round/>
+                      <a:headEnd type="none" w="med" len="med"/>
+                      <a:tailEnd type="none" w="med" len="med"/>
+                    </a:lnB>
+                    <a:solidFill>
+                      <a:schemeClr val="tx2"/>
+                    </a:solidFill>
+                  </a:tcPr>
+                </a:tc>
+                <a:tc>
+                  <a:txBody>
+                    <a:bodyPr/>
+                    <a:lstStyle/>
+                    <a:p>
+                      <a:pPr indent="0" marL="0">
+                        <a:buNone/>
+                      </a:pPr>
+                      <a:r>
+                        <a:rPr lang="en-US" sz="1400" b="1" dirty="0">
+                          <a:solidFill>
+                            <a:schemeClr val="bg1"/>
+                          </a:solidFill>
+                        </a:rPr>
+                        <a:t>Own-lab advantage</a:t>
+                      </a:r>
+                      <a:endParaRPr lang="en-US" sz="1400" dirty="0"/>
+                    </a:p>
+                  </a:txBody>
+                  <a:tcPr marL="91440" marR="91440" marT="45720" marB="45720">
+                    <a:lnL w="6350" cap="flat" cmpd="sng" algn="ctr">
+                      <a:solidFill>
+                        <a:srgbClr val="DDE5E4"/>
+                      </a:solidFill>
+                      <a:prstDash val="solid"/>
+                      <a:round/>
+                      <a:headEnd type="none" w="med" len="med"/>
+                      <a:tailEnd type="none" w="med" len="med"/>
+                    </a:lnL>
+                    <a:lnR w="6350" cap="flat" cmpd="sng" algn="ctr">
+                      <a:solidFill>
+                        <a:srgbClr val="DDE5E4"/>
+                      </a:solidFill>
+                      <a:prstDash val="solid"/>
+                      <a:round/>
+                      <a:headEnd type="none" w="med" len="med"/>
+                      <a:tailEnd type="none" w="med" len="med"/>
+                    </a:lnR>
+                    <a:lnT w="6350" cap="flat" cmpd="sng" algn="ctr">
+                      <a:solidFill>
+                        <a:srgbClr val="DDE5E4"/>
+                      </a:solidFill>
+                      <a:prstDash val="solid"/>
+                      <a:round/>
+                      <a:headEnd type="none" w="med" len="med"/>
+                      <a:tailEnd type="none" w="med" len="med"/>
+                    </a:lnT>
+                    <a:lnB w="6350" cap="flat" cmpd="sng" algn="ctr">
+                      <a:solidFill>
+                        <a:srgbClr val="DDE5E4"/>
+                      </a:solidFill>
+                      <a:prstDash val="solid"/>
+                      <a:round/>
+                      <a:headEnd type="none" w="med" len="med"/>
+                      <a:tailEnd type="none" w="med" len="med"/>
+                    </a:lnB>
+                    <a:solidFill>
+                      <a:schemeClr val="tx2"/>
+                    </a:solidFill>
+                  </a:tcPr>
+                </a:tc>
+              </a:tr>
+              <a:tr h="384048">
+                <a:tc>
+                  <a:txBody>
+                    <a:bodyPr/>
+                    <a:lstStyle/>
+                    <a:p>
+                      <a:pPr indent="0" marL="0">
+                        <a:buNone/>
+                      </a:pPr>
+                      <a:r>
+                        <a:rPr lang="en-US" sz="1400" dirty="0">
+                          <a:solidFill>
+                            <a:schemeClr val="tx1"/>
+                          </a:solidFill>
+                        </a:rPr>
+                        <a:t>Stav14, Stav8, Stav18, Stav17 (hardest)</a:t>
+                      </a:r>
+                      <a:endParaRPr lang="en-US" sz="1400" dirty="0"/>
+                    </a:p>
+                  </a:txBody>
+                  <a:tcPr marL="91440" marR="91440" marT="45720" marB="45720">
+                    <a:lnL w="6350" cap="flat" cmpd="sng" algn="ctr">
+                      <a:solidFill>
+                        <a:srgbClr val="DDE5E4"/>
+                      </a:solidFill>
+                      <a:prstDash val="solid"/>
+                      <a:round/>
+                      <a:headEnd type="none" w="med" len="med"/>
+                      <a:tailEnd type="none" w="med" len="med"/>
+                    </a:lnL>
+                    <a:lnR w="6350" cap="flat" cmpd="sng" algn="ctr">
+                      <a:solidFill>
+                        <a:srgbClr val="DDE5E4"/>
+                      </a:solidFill>
+                      <a:prstDash val="solid"/>
+                      <a:round/>
+                      <a:headEnd type="none" w="med" len="med"/>
+                      <a:tailEnd type="none" w="med" len="med"/>
+                    </a:lnR>
+                    <a:lnT w="6350" cap="flat" cmpd="sng" algn="ctr">
+                      <a:solidFill>
+                        <a:srgbClr val="DDE5E4"/>
+                      </a:solidFill>
+                      <a:prstDash val="solid"/>
+                      <a:round/>
+                      <a:headEnd type="none" w="med" len="med"/>
+                      <a:tailEnd type="none" w="med" len="med"/>
+                    </a:lnT>
+                    <a:lnB w="6350" cap="flat" cmpd="sng" algn="ctr">
+                      <a:solidFill>
+                        <a:srgbClr val="DDE5E4"/>
+                      </a:solidFill>
+                      <a:prstDash val="solid"/>
+                      <a:round/>
+                      <a:headEnd type="none" w="med" len="med"/>
+                      <a:tailEnd type="none" w="med" len="med"/>
+                    </a:lnB>
+                    <a:solidFill>
+                      <a:schemeClr val="bg1"/>
+                    </a:solidFill>
+                  </a:tcPr>
+                </a:tc>
+                <a:tc>
+                  <a:txBody>
+                    <a:bodyPr/>
+                    <a:lstStyle/>
+                    <a:p>
+                      <a:pPr indent="0" marL="0">
+                        <a:buNone/>
+                      </a:pPr>
+                      <a:r>
+                        <a:rPr lang="en-US" sz="1400" b="1" dirty="0">
+                          <a:solidFill>
+                            <a:schemeClr val="tx1"/>
+                          </a:solidFill>
+                        </a:rPr>
+                        <a:t>0.833</a:t>
+                      </a:r>
+                      <a:endParaRPr lang="en-US" sz="1400" dirty="0"/>
+                    </a:p>
+                  </a:txBody>
+                  <a:tcPr marL="91440" marR="91440" marT="45720" marB="45720">
+                    <a:lnL w="6350" cap="flat" cmpd="sng" algn="ctr">
+                      <a:solidFill>
+                        <a:srgbClr val="DDE5E4"/>
+                      </a:solidFill>
+                      <a:prstDash val="solid"/>
+                      <a:round/>
+                      <a:headEnd type="none" w="med" len="med"/>
+                      <a:tailEnd type="none" w="med" len="med"/>
+                    </a:lnL>
+                    <a:lnR w="6350" cap="flat" cmpd="sng" algn="ctr">
+                      <a:solidFill>
+                        <a:srgbClr val="DDE5E4"/>
+                      </a:solidFill>
+                      <a:prstDash val="solid"/>
+                      <a:round/>
+                      <a:headEnd type="none" w="med" len="med"/>
+                      <a:tailEnd type="none" w="med" len="med"/>
+                    </a:lnR>
+                    <a:lnT w="6350" cap="flat" cmpd="sng" algn="ctr">
+                      <a:solidFill>
+                        <a:srgbClr val="DDE5E4"/>
+                      </a:solidFill>
+                      <a:prstDash val="solid"/>
+                      <a:round/>
+                      <a:headEnd type="none" w="med" len="med"/>
+                      <a:tailEnd type="none" w="med" len="med"/>
+                    </a:lnT>
+                    <a:lnB w="6350" cap="flat" cmpd="sng" algn="ctr">
+                      <a:solidFill>
+                        <a:srgbClr val="DDE5E4"/>
+                      </a:solidFill>
+                      <a:prstDash val="solid"/>
+                      <a:round/>
+                      <a:headEnd type="none" w="med" len="med"/>
+                      <a:tailEnd type="none" w="med" len="med"/>
+                    </a:lnB>
+                    <a:solidFill>
+                      <a:schemeClr val="bg1"/>
+                    </a:solidFill>
+                  </a:tcPr>
+                </a:tc>
+                <a:tc>
+                  <a:txBody>
+                    <a:bodyPr/>
+                    <a:lstStyle/>
+                    <a:p>
+                      <a:pPr indent="0" marL="0">
+                        <a:buNone/>
+                      </a:pPr>
+                      <a:r>
+                        <a:rPr lang="en-US" sz="1400" dirty="0">
+                          <a:solidFill>
+                            <a:schemeClr val="tx1"/>
+                          </a:solidFill>
+                        </a:rPr>
+                        <a:t>0.808</a:t>
+                      </a:r>
+                      <a:endParaRPr lang="en-US" sz="1400" dirty="0"/>
+                    </a:p>
+                  </a:txBody>
+                  <a:tcPr marL="91440" marR="91440" marT="45720" marB="45720">
+                    <a:lnL w="6350" cap="flat" cmpd="sng" algn="ctr">
+                      <a:solidFill>
+                        <a:srgbClr val="DDE5E4"/>
+                      </a:solidFill>
+                      <a:prstDash val="solid"/>
+                      <a:round/>
+                      <a:headEnd type="none" w="med" len="med"/>
+                      <a:tailEnd type="none" w="med" len="med"/>
+                    </a:lnL>
+                    <a:lnR w="6350" cap="flat" cmpd="sng" algn="ctr">
+                      <a:solidFill>
+                        <a:srgbClr val="DDE5E4"/>
+                      </a:solidFill>
+                      <a:prstDash val="solid"/>
+                      <a:round/>
+                      <a:headEnd type="none" w="med" len="med"/>
+                      <a:tailEnd type="none" w="med" len="med"/>
+                    </a:lnR>
+                    <a:lnT w="6350" cap="flat" cmpd="sng" algn="ctr">
+                      <a:solidFill>
+                        <a:srgbClr val="DDE5E4"/>
+                      </a:solidFill>
+                      <a:prstDash val="solid"/>
+                      <a:round/>
+                      <a:headEnd type="none" w="med" len="med"/>
+                      <a:tailEnd type="none" w="med" len="med"/>
+                    </a:lnT>
+                    <a:lnB w="6350" cap="flat" cmpd="sng" algn="ctr">
+                      <a:solidFill>
+                        <a:srgbClr val="DDE5E4"/>
+                      </a:solidFill>
+                      <a:prstDash val="solid"/>
+                      <a:round/>
+                      <a:headEnd type="none" w="med" len="med"/>
+                      <a:tailEnd type="none" w="med" len="med"/>
+                    </a:lnB>
+                    <a:solidFill>
+                      <a:schemeClr val="bg1"/>
+                    </a:solidFill>
+                  </a:tcPr>
+                </a:tc>
+                <a:tc>
+                  <a:txBody>
+                    <a:bodyPr/>
+                    <a:lstStyle/>
+                    <a:p>
+                      <a:pPr indent="0" marL="0">
+                        <a:buNone/>
+                      </a:pPr>
+                      <a:r>
+                        <a:rPr lang="en-US" sz="1400" dirty="0">
+                          <a:solidFill>
+                            <a:schemeClr val="tx1"/>
+                          </a:solidFill>
+                        </a:rPr>
+                        <a:t>+0.025</a:t>
+                      </a:r>
+                      <a:endParaRPr lang="en-US" sz="1400" dirty="0"/>
+                    </a:p>
+                  </a:txBody>
+                  <a:tcPr marL="91440" marR="91440" marT="45720" marB="45720">
+                    <a:lnL w="6350" cap="flat" cmpd="sng" algn="ctr">
+                      <a:solidFill>
+                        <a:srgbClr val="DDE5E4"/>
+                      </a:solidFill>
+                      <a:prstDash val="solid"/>
+                      <a:round/>
+                      <a:headEnd type="none" w="med" len="med"/>
+                      <a:tailEnd type="none" w="med" len="med"/>
+                    </a:lnL>
+                    <a:lnR w="6350" cap="flat" cmpd="sng" algn="ctr">
+                      <a:solidFill>
+                        <a:srgbClr val="DDE5E4"/>
+                      </a:solidFill>
+                      <a:prstDash val="solid"/>
+                      <a:round/>
+                      <a:headEnd type="none" w="med" len="med"/>
+                      <a:tailEnd type="none" w="med" len="med"/>
+                    </a:lnR>
+                    <a:lnT w="6350" cap="flat" cmpd="sng" algn="ctr">
+                      <a:solidFill>
+                        <a:srgbClr val="DDE5E4"/>
+                      </a:solidFill>
+                      <a:prstDash val="solid"/>
+                      <a:round/>
+                      <a:headEnd type="none" w="med" len="med"/>
+                      <a:tailEnd type="none" w="med" len="med"/>
+                    </a:lnT>
+                    <a:lnB w="6350" cap="flat" cmpd="sng" algn="ctr">
+                      <a:solidFill>
+                        <a:srgbClr val="DDE5E4"/>
+                      </a:solidFill>
+                      <a:prstDash val="solid"/>
+                      <a:round/>
+                      <a:headEnd type="none" w="med" len="med"/>
+                      <a:tailEnd type="none" w="med" len="med"/>
+                    </a:lnB>
+                    <a:solidFill>
+                      <a:schemeClr val="bg1"/>
+                    </a:solidFill>
+                  </a:tcPr>
+                </a:tc>
+              </a:tr>
+              <a:tr h="384048">
+                <a:tc>
+                  <a:txBody>
+                    <a:bodyPr/>
+                    <a:lstStyle/>
+                    <a:p>
+                      <a:pPr indent="0" marL="0">
+                        <a:buNone/>
+                      </a:pPr>
+                      <a:r>
+                        <a:rPr lang="en-US" sz="1400" dirty="0">
+                          <a:solidFill>
+                            <a:schemeClr val="tx1"/>
+                          </a:solidFill>
+                        </a:rPr>
+                        <a:t>Stav4, Stav16, Stav14, Stav6</a:t>
+                      </a:r>
+                      <a:endParaRPr lang="en-US" sz="1400" dirty="0"/>
+                    </a:p>
+                  </a:txBody>
+                  <a:tcPr marL="91440" marR="91440" marT="45720" marB="45720">
+                    <a:lnL w="6350" cap="flat" cmpd="sng" algn="ctr">
+                      <a:solidFill>
+                        <a:srgbClr val="DDE5E4"/>
+                      </a:solidFill>
+                      <a:prstDash val="solid"/>
+                      <a:round/>
+                      <a:headEnd type="none" w="med" len="med"/>
+                      <a:tailEnd type="none" w="med" len="med"/>
+                    </a:lnL>
+                    <a:lnR w="6350" cap="flat" cmpd="sng" algn="ctr">
+                      <a:solidFill>
+                        <a:srgbClr val="DDE5E4"/>
+                      </a:solidFill>
+                      <a:prstDash val="solid"/>
+                      <a:round/>
+                      <a:headEnd type="none" w="med" len="med"/>
+                      <a:tailEnd type="none" w="med" len="med"/>
+                    </a:lnR>
+                    <a:lnT w="6350" cap="flat" cmpd="sng" algn="ctr">
+                      <a:solidFill>
+                        <a:srgbClr val="DDE5E4"/>
+                      </a:solidFill>
+                      <a:prstDash val="solid"/>
+                      <a:round/>
+                      <a:headEnd type="none" w="med" len="med"/>
+                      <a:tailEnd type="none" w="med" len="med"/>
+                    </a:lnT>
+                    <a:lnB w="6350" cap="flat" cmpd="sng" algn="ctr">
+                      <a:solidFill>
+                        <a:srgbClr val="DDE5E4"/>
+                      </a:solidFill>
+                      <a:prstDash val="solid"/>
+                      <a:round/>
+                      <a:headEnd type="none" w="med" len="med"/>
+                      <a:tailEnd type="none" w="med" len="med"/>
+                    </a:lnB>
+                    <a:solidFill>
+                      <a:schemeClr val="bg1"/>
+                    </a:solidFill>
+                  </a:tcPr>
+                </a:tc>
+                <a:tc>
+                  <a:txBody>
+                    <a:bodyPr/>
+                    <a:lstStyle/>
+                    <a:p>
+                      <a:pPr indent="0" marL="0">
+                        <a:buNone/>
+                      </a:pPr>
+                      <a:r>
+                        <a:rPr lang="en-US" sz="1400" b="1" dirty="0">
+                          <a:solidFill>
+                            <a:schemeClr val="tx1"/>
+                          </a:solidFill>
+                        </a:rPr>
+                        <a:t>0.848</a:t>
+                      </a:r>
+                      <a:endParaRPr lang="en-US" sz="1400" dirty="0"/>
+                    </a:p>
+                  </a:txBody>
+                  <a:tcPr marL="91440" marR="91440" marT="45720" marB="45720">
+                    <a:lnL w="6350" cap="flat" cmpd="sng" algn="ctr">
+                      <a:solidFill>
+                        <a:srgbClr val="DDE5E4"/>
+                      </a:solidFill>
+                      <a:prstDash val="solid"/>
+                      <a:round/>
+                      <a:headEnd type="none" w="med" len="med"/>
+                      <a:tailEnd type="none" w="med" len="med"/>
+                    </a:lnL>
+                    <a:lnR w="6350" cap="flat" cmpd="sng" algn="ctr">
+                      <a:solidFill>
+                        <a:srgbClr val="DDE5E4"/>
+                      </a:solidFill>
+                      <a:prstDash val="solid"/>
+                      <a:round/>
+                      <a:headEnd type="none" w="med" len="med"/>
+                      <a:tailEnd type="none" w="med" len="med"/>
+                    </a:lnR>
+                    <a:lnT w="6350" cap="flat" cmpd="sng" algn="ctr">
+                      <a:solidFill>
+                        <a:srgbClr val="DDE5E4"/>
+                      </a:solidFill>
+                      <a:prstDash val="solid"/>
+                      <a:round/>
+                      <a:headEnd type="none" w="med" len="med"/>
+                      <a:tailEnd type="none" w="med" len="med"/>
+                    </a:lnT>
+                    <a:lnB w="6350" cap="flat" cmpd="sng" algn="ctr">
+                      <a:solidFill>
+                        <a:srgbClr val="DDE5E4"/>
+                      </a:solidFill>
+                      <a:prstDash val="solid"/>
+                      <a:round/>
+                      <a:headEnd type="none" w="med" len="med"/>
+                      <a:tailEnd type="none" w="med" len="med"/>
+                    </a:lnB>
+                    <a:solidFill>
+                      <a:schemeClr val="bg1"/>
+                    </a:solidFill>
+                  </a:tcPr>
+                </a:tc>
+                <a:tc>
+                  <a:txBody>
+                    <a:bodyPr/>
+                    <a:lstStyle/>
+                    <a:p>
+                      <a:pPr indent="0" marL="0">
+                        <a:buNone/>
+                      </a:pPr>
+                      <a:r>
+                        <a:rPr lang="en-US" sz="1400" dirty="0">
+                          <a:solidFill>
+                            <a:schemeClr val="tx1"/>
+                          </a:solidFill>
+                        </a:rPr>
+                        <a:t>0.834</a:t>
+                      </a:r>
+                      <a:endParaRPr lang="en-US" sz="1400" dirty="0"/>
+                    </a:p>
+                  </a:txBody>
+                  <a:tcPr marL="91440" marR="91440" marT="45720" marB="45720">
+                    <a:lnL w="6350" cap="flat" cmpd="sng" algn="ctr">
+                      <a:solidFill>
+                        <a:srgbClr val="DDE5E4"/>
+                      </a:solidFill>
+                      <a:prstDash val="solid"/>
+                      <a:round/>
+                      <a:headEnd type="none" w="med" len="med"/>
+                      <a:tailEnd type="none" w="med" len="med"/>
+                    </a:lnL>
+                    <a:lnR w="6350" cap="flat" cmpd="sng" algn="ctr">
+                      <a:solidFill>
+                        <a:srgbClr val="DDE5E4"/>
+                      </a:solidFill>
+                      <a:prstDash val="solid"/>
+                      <a:round/>
+                      <a:headEnd type="none" w="med" len="med"/>
+                      <a:tailEnd type="none" w="med" len="med"/>
+                    </a:lnR>
+                    <a:lnT w="6350" cap="flat" cmpd="sng" algn="ctr">
+                      <a:solidFill>
+                        <a:srgbClr val="DDE5E4"/>
+                      </a:solidFill>
+                      <a:prstDash val="solid"/>
+                      <a:round/>
+                      <a:headEnd type="none" w="med" len="med"/>
+                      <a:tailEnd type="none" w="med" len="med"/>
+                    </a:lnT>
+                    <a:lnB w="6350" cap="flat" cmpd="sng" algn="ctr">
+                      <a:solidFill>
+                        <a:srgbClr val="DDE5E4"/>
+                      </a:solidFill>
+                      <a:prstDash val="solid"/>
+                      <a:round/>
+                      <a:headEnd type="none" w="med" len="med"/>
+                      <a:tailEnd type="none" w="med" len="med"/>
+                    </a:lnB>
+                    <a:solidFill>
+                      <a:schemeClr val="bg1"/>
+                    </a:solidFill>
+                  </a:tcPr>
+                </a:tc>
+                <a:tc>
+                  <a:txBody>
+                    <a:bodyPr/>
+                    <a:lstStyle/>
+                    <a:p>
+                      <a:pPr indent="0" marL="0">
+                        <a:buNone/>
+                      </a:pPr>
+                      <a:r>
+                        <a:rPr lang="en-US" sz="1400" dirty="0">
+                          <a:solidFill>
+                            <a:schemeClr val="tx1"/>
+                          </a:solidFill>
+                        </a:rPr>
+                        <a:t>+0.014</a:t>
+                      </a:r>
+                      <a:endParaRPr lang="en-US" sz="1400" dirty="0"/>
+                    </a:p>
+                  </a:txBody>
+                  <a:tcPr marL="91440" marR="91440" marT="45720" marB="45720">
+                    <a:lnL w="6350" cap="flat" cmpd="sng" algn="ctr">
+                      <a:solidFill>
+                        <a:srgbClr val="DDE5E4"/>
+                      </a:solidFill>
+                      <a:prstDash val="solid"/>
+                      <a:round/>
+                      <a:headEnd type="none" w="med" len="med"/>
+                      <a:tailEnd type="none" w="med" len="med"/>
+                    </a:lnL>
+                    <a:lnR w="6350" cap="flat" cmpd="sng" algn="ctr">
+                      <a:solidFill>
+                        <a:srgbClr val="DDE5E4"/>
+                      </a:solidFill>
+                      <a:prstDash val="solid"/>
+                      <a:round/>
+                      <a:headEnd type="none" w="med" len="med"/>
+                      <a:tailEnd type="none" w="med" len="med"/>
+                    </a:lnR>
+                    <a:lnT w="6350" cap="flat" cmpd="sng" algn="ctr">
+                      <a:solidFill>
+                        <a:srgbClr val="DDE5E4"/>
+                      </a:solidFill>
+                      <a:prstDash val="solid"/>
+                      <a:round/>
+                      <a:headEnd type="none" w="med" len="med"/>
+                      <a:tailEnd type="none" w="med" len="med"/>
+                    </a:lnT>
+                    <a:lnB w="6350" cap="flat" cmpd="sng" algn="ctr">
+                      <a:solidFill>
+                        <a:srgbClr val="DDE5E4"/>
+                      </a:solidFill>
+                      <a:prstDash val="solid"/>
+                      <a:round/>
+                      <a:headEnd type="none" w="med" len="med"/>
+                      <a:tailEnd type="none" w="med" len="med"/>
+                    </a:lnB>
+                    <a:solidFill>
+                      <a:schemeClr val="bg1"/>
+                    </a:solidFill>
+                  </a:tcPr>
+                </a:tc>
+              </a:tr>
+              <a:tr h="384048">
+                <a:tc>
+                  <a:txBody>
+                    <a:bodyPr/>
+                    <a:lstStyle/>
+                    <a:p>
+                      <a:pPr indent="0" marL="0">
+                        <a:buNone/>
+                      </a:pPr>
+                      <a:r>
+                        <a:rPr lang="en-US" sz="1400" dirty="0">
+                          <a:solidFill>
+                            <a:schemeClr val="tx1"/>
+                          </a:solidFill>
+                        </a:rPr>
+                        <a:t>Stav9, Stav13, Stav20, Stav19</a:t>
+                      </a:r>
+                      <a:endParaRPr lang="en-US" sz="1400" dirty="0"/>
+                    </a:p>
+                  </a:txBody>
+                  <a:tcPr marL="91440" marR="91440" marT="45720" marB="45720">
+                    <a:lnL w="6350" cap="flat" cmpd="sng" algn="ctr">
+                      <a:solidFill>
+                        <a:srgbClr val="DDE5E4"/>
+                      </a:solidFill>
+                      <a:prstDash val="solid"/>
+                      <a:round/>
+                      <a:headEnd type="none" w="med" len="med"/>
+                      <a:tailEnd type="none" w="med" len="med"/>
+                    </a:lnL>
+                    <a:lnR w="6350" cap="flat" cmpd="sng" algn="ctr">
+                      <a:solidFill>
+                        <a:srgbClr val="DDE5E4"/>
+                      </a:solidFill>
+                      <a:prstDash val="solid"/>
+                      <a:round/>
+                      <a:headEnd type="none" w="med" len="med"/>
+                      <a:tailEnd type="none" w="med" len="med"/>
+                    </a:lnR>
+                    <a:lnT w="6350" cap="flat" cmpd="sng" algn="ctr">
+                      <a:solidFill>
+                        <a:srgbClr val="DDE5E4"/>
+                      </a:solidFill>
+                      <a:prstDash val="solid"/>
+                      <a:round/>
+                      <a:headEnd type="none" w="med" len="med"/>
+                      <a:tailEnd type="none" w="med" len="med"/>
+                    </a:lnT>
+                    <a:lnB w="6350" cap="flat" cmpd="sng" algn="ctr">
+                      <a:solidFill>
+                        <a:srgbClr val="DDE5E4"/>
+                      </a:solidFill>
+                      <a:prstDash val="solid"/>
+                      <a:round/>
+                      <a:headEnd type="none" w="med" len="med"/>
+                      <a:tailEnd type="none" w="med" len="med"/>
+                    </a:lnB>
+                    <a:solidFill>
+                      <a:schemeClr val="bg1"/>
+                    </a:solidFill>
+                  </a:tcPr>
+                </a:tc>
+                <a:tc>
+                  <a:txBody>
+                    <a:bodyPr/>
+                    <a:lstStyle/>
+                    <a:p>
+                      <a:pPr indent="0" marL="0">
+                        <a:buNone/>
+                      </a:pPr>
+                      <a:r>
+                        <a:rPr lang="en-US" sz="1400" b="1" dirty="0">
+                          <a:solidFill>
+                            <a:schemeClr val="tx1"/>
+                          </a:solidFill>
+                        </a:rPr>
+                        <a:t>0.886</a:t>
+                      </a:r>
+                      <a:endParaRPr lang="en-US" sz="1400" dirty="0"/>
+                    </a:p>
+                  </a:txBody>
+                  <a:tcPr marL="91440" marR="91440" marT="45720" marB="45720">
+                    <a:lnL w="6350" cap="flat" cmpd="sng" algn="ctr">
+                      <a:solidFill>
+                        <a:srgbClr val="DDE5E4"/>
+                      </a:solidFill>
+                      <a:prstDash val="solid"/>
+                      <a:round/>
+                      <a:headEnd type="none" w="med" len="med"/>
+                      <a:tailEnd type="none" w="med" len="med"/>
+                    </a:lnL>
+                    <a:lnR w="6350" cap="flat" cmpd="sng" algn="ctr">
+                      <a:solidFill>
+                        <a:srgbClr val="DDE5E4"/>
+                      </a:solidFill>
+                      <a:prstDash val="solid"/>
+                      <a:round/>
+                      <a:headEnd type="none" w="med" len="med"/>
+                      <a:tailEnd type="none" w="med" len="med"/>
+                    </a:lnR>
+                    <a:lnT w="6350" cap="flat" cmpd="sng" algn="ctr">
+                      <a:solidFill>
+                        <a:srgbClr val="DDE5E4"/>
+                      </a:solidFill>
+                      <a:prstDash val="solid"/>
+                      <a:round/>
+                      <a:headEnd type="none" w="med" len="med"/>
+                      <a:tailEnd type="none" w="med" len="med"/>
+                    </a:lnT>
+                    <a:lnB w="6350" cap="flat" cmpd="sng" algn="ctr">
+                      <a:solidFill>
+                        <a:srgbClr val="DDE5E4"/>
+                      </a:solidFill>
+                      <a:prstDash val="solid"/>
+                      <a:round/>
+                      <a:headEnd type="none" w="med" len="med"/>
+                      <a:tailEnd type="none" w="med" len="med"/>
+                    </a:lnB>
+                    <a:solidFill>
+                      <a:schemeClr val="bg1"/>
+                    </a:solidFill>
+                  </a:tcPr>
+                </a:tc>
+                <a:tc>
+                  <a:txBody>
+                    <a:bodyPr/>
+                    <a:lstStyle/>
+                    <a:p>
+                      <a:pPr indent="0" marL="0">
+                        <a:buNone/>
+                      </a:pPr>
+                      <a:r>
+                        <a:rPr lang="en-US" sz="1400" dirty="0">
+                          <a:solidFill>
+                            <a:schemeClr val="tx1"/>
+                          </a:solidFill>
+                        </a:rPr>
+                        <a:t>0.855</a:t>
+                      </a:r>
+                      <a:endParaRPr lang="en-US" sz="1400" dirty="0"/>
+                    </a:p>
+                  </a:txBody>
+                  <a:tcPr marL="91440" marR="91440" marT="45720" marB="45720">
+                    <a:lnL w="6350" cap="flat" cmpd="sng" algn="ctr">
+                      <a:solidFill>
+                        <a:srgbClr val="DDE5E4"/>
+                      </a:solidFill>
+                      <a:prstDash val="solid"/>
+                      <a:round/>
+                      <a:headEnd type="none" w="med" len="med"/>
+                      <a:tailEnd type="none" w="med" len="med"/>
+                    </a:lnL>
+                    <a:lnR w="6350" cap="flat" cmpd="sng" algn="ctr">
+                      <a:solidFill>
+                        <a:srgbClr val="DDE5E4"/>
+                      </a:solidFill>
+                      <a:prstDash val="solid"/>
+                      <a:round/>
+                      <a:headEnd type="none" w="med" len="med"/>
+                      <a:tailEnd type="none" w="med" len="med"/>
+                    </a:lnR>
+                    <a:lnT w="6350" cap="flat" cmpd="sng" algn="ctr">
+                      <a:solidFill>
+                        <a:srgbClr val="DDE5E4"/>
+                      </a:solidFill>
+                      <a:prstDash val="solid"/>
+                      <a:round/>
+                      <a:headEnd type="none" w="med" len="med"/>
+                      <a:tailEnd type="none" w="med" len="med"/>
+                    </a:lnT>
+                    <a:lnB w="6350" cap="flat" cmpd="sng" algn="ctr">
+                      <a:solidFill>
+                        <a:srgbClr val="DDE5E4"/>
+                      </a:solidFill>
+                      <a:prstDash val="solid"/>
+                      <a:round/>
+                      <a:headEnd type="none" w="med" len="med"/>
+                      <a:tailEnd type="none" w="med" len="med"/>
+                    </a:lnB>
+                    <a:solidFill>
+                      <a:schemeClr val="bg1"/>
+                    </a:solidFill>
+                  </a:tcPr>
+                </a:tc>
+                <a:tc>
+                  <a:txBody>
+                    <a:bodyPr/>
+                    <a:lstStyle/>
+                    <a:p>
+                      <a:pPr indent="0" marL="0">
+                        <a:buNone/>
+                      </a:pPr>
+                      <a:r>
+                        <a:rPr lang="en-US" sz="1400" dirty="0">
+                          <a:solidFill>
+                            <a:schemeClr val="tx1"/>
+                          </a:solidFill>
+                        </a:rPr>
+                        <a:t>+0.031</a:t>
+                      </a:r>
+                      <a:endParaRPr lang="en-US" sz="1400" dirty="0"/>
+                    </a:p>
+                  </a:txBody>
+                  <a:tcPr marL="91440" marR="91440" marT="45720" marB="45720">
+                    <a:lnL w="6350" cap="flat" cmpd="sng" algn="ctr">
+                      <a:solidFill>
+                        <a:srgbClr val="DDE5E4"/>
+                      </a:solidFill>
+                      <a:prstDash val="solid"/>
+                      <a:round/>
+                      <a:headEnd type="none" w="med" len="med"/>
+                      <a:tailEnd type="none" w="med" len="med"/>
+                    </a:lnL>
+                    <a:lnR w="6350" cap="flat" cmpd="sng" algn="ctr">
+                      <a:solidFill>
+                        <a:srgbClr val="DDE5E4"/>
+                      </a:solidFill>
+                      <a:prstDash val="solid"/>
+                      <a:round/>
+                      <a:headEnd type="none" w="med" len="med"/>
+                      <a:tailEnd type="none" w="med" len="med"/>
+                    </a:lnR>
+                    <a:lnT w="6350" cap="flat" cmpd="sng" algn="ctr">
+                      <a:solidFill>
+                        <a:srgbClr val="DDE5E4"/>
+                      </a:solidFill>
+                      <a:prstDash val="solid"/>
+                      <a:round/>
+                      <a:headEnd type="none" w="med" len="med"/>
+                      <a:tailEnd type="none" w="med" len="med"/>
+                    </a:lnT>
+                    <a:lnB w="6350" cap="flat" cmpd="sng" algn="ctr">
+                      <a:solidFill>
+                        <a:srgbClr val="DDE5E4"/>
+                      </a:solidFill>
+                      <a:prstDash val="solid"/>
+                      <a:round/>
+                      <a:headEnd type="none" w="med" len="med"/>
+                      <a:tailEnd type="none" w="med" len="med"/>
+                    </a:lnB>
+                    <a:solidFill>
+                      <a:schemeClr val="bg1"/>
+                    </a:solidFill>
+                  </a:tcPr>
+                </a:tc>
+              </a:tr>
+              <a:tr h="384048">
+                <a:tc>
+                  <a:txBody>
+                    <a:bodyPr/>
+                    <a:lstStyle/>
+                    <a:p>
+                      <a:pPr indent="0" marL="0">
+                        <a:buNone/>
+                      </a:pPr>
+                      <a:r>
+                        <a:rPr lang="en-US" sz="1400" dirty="0">
+                          <a:solidFill>
+                            <a:schemeClr val="tx1"/>
+                          </a:solidFill>
+                        </a:rPr>
+                        <a:t>Stav6, Stav18, Stav16, Stav14</a:t>
+                      </a:r>
+                      <a:endParaRPr lang="en-US" sz="1400" dirty="0"/>
+                    </a:p>
+                  </a:txBody>
+                  <a:tcPr marL="91440" marR="91440" marT="45720" marB="45720">
+                    <a:lnL w="6350" cap="flat" cmpd="sng" algn="ctr">
+                      <a:solidFill>
+                        <a:srgbClr val="DDE5E4"/>
+                      </a:solidFill>
+                      <a:prstDash val="solid"/>
+                      <a:round/>
+                      <a:headEnd type="none" w="med" len="med"/>
+                      <a:tailEnd type="none" w="med" len="med"/>
+                    </a:lnL>
+                    <a:lnR w="6350" cap="flat" cmpd="sng" algn="ctr">
+                      <a:solidFill>
+                        <a:srgbClr val="DDE5E4"/>
+                      </a:solidFill>
+                      <a:prstDash val="solid"/>
+                      <a:round/>
+                      <a:headEnd type="none" w="med" len="med"/>
+                      <a:tailEnd type="none" w="med" len="med"/>
+                    </a:lnR>
+                    <a:lnT w="6350" cap="flat" cmpd="sng" algn="ctr">
+                      <a:solidFill>
+                        <a:srgbClr val="DDE5E4"/>
+                      </a:solidFill>
+                      <a:prstDash val="solid"/>
+                      <a:round/>
+                      <a:headEnd type="none" w="med" len="med"/>
+                      <a:tailEnd type="none" w="med" len="med"/>
+                    </a:lnT>
+                    <a:lnB w="6350" cap="flat" cmpd="sng" algn="ctr">
+                      <a:solidFill>
+                        <a:srgbClr val="DDE5E4"/>
+                      </a:solidFill>
+                      <a:prstDash val="solid"/>
+                      <a:round/>
+                      <a:headEnd type="none" w="med" len="med"/>
+                      <a:tailEnd type="none" w="med" len="med"/>
+                    </a:lnB>
+                    <a:solidFill>
+                      <a:schemeClr val="bg1"/>
+                    </a:solidFill>
+                  </a:tcPr>
+                </a:tc>
+                <a:tc>
+                  <a:txBody>
+                    <a:bodyPr/>
+                    <a:lstStyle/>
+                    <a:p>
+                      <a:pPr indent="0" marL="0">
+                        <a:buNone/>
+                      </a:pPr>
+                      <a:r>
+                        <a:rPr lang="en-US" sz="1400" b="1" dirty="0">
+                          <a:solidFill>
+                            <a:schemeClr val="tx1"/>
+                          </a:solidFill>
+                        </a:rPr>
+                        <a:t>0.831</a:t>
+                      </a:r>
+                      <a:endParaRPr lang="en-US" sz="1400" dirty="0"/>
+                    </a:p>
+                  </a:txBody>
+                  <a:tcPr marL="91440" marR="91440" marT="45720" marB="45720">
+                    <a:lnL w="6350" cap="flat" cmpd="sng" algn="ctr">
+                      <a:solidFill>
+                        <a:srgbClr val="DDE5E4"/>
+                      </a:solidFill>
+                      <a:prstDash val="solid"/>
+                      <a:round/>
+                      <a:headEnd type="none" w="med" len="med"/>
+                      <a:tailEnd type="none" w="med" len="med"/>
+                    </a:lnL>
+                    <a:lnR w="6350" cap="flat" cmpd="sng" algn="ctr">
+                      <a:solidFill>
+                        <a:srgbClr val="DDE5E4"/>
+                      </a:solidFill>
+                      <a:prstDash val="solid"/>
+                      <a:round/>
+                      <a:headEnd type="none" w="med" len="med"/>
+                      <a:tailEnd type="none" w="med" len="med"/>
+                    </a:lnR>
+                    <a:lnT w="6350" cap="flat" cmpd="sng" algn="ctr">
+                      <a:solidFill>
+                        <a:srgbClr val="DDE5E4"/>
+                      </a:solidFill>
+                      <a:prstDash val="solid"/>
+                      <a:round/>
+                      <a:headEnd type="none" w="med" len="med"/>
+                      <a:tailEnd type="none" w="med" len="med"/>
+                    </a:lnT>
+                    <a:lnB w="6350" cap="flat" cmpd="sng" algn="ctr">
+                      <a:solidFill>
+                        <a:srgbClr val="DDE5E4"/>
+                      </a:solidFill>
+                      <a:prstDash val="solid"/>
+                      <a:round/>
+                      <a:headEnd type="none" w="med" len="med"/>
+                      <a:tailEnd type="none" w="med" len="med"/>
+                    </a:lnB>
+                    <a:solidFill>
+                      <a:schemeClr val="bg1"/>
+                    </a:solidFill>
+                  </a:tcPr>
+                </a:tc>
+                <a:tc>
+                  <a:txBody>
+                    <a:bodyPr/>
+                    <a:lstStyle/>
+                    <a:p>
+                      <a:pPr indent="0" marL="0">
+                        <a:buNone/>
+                      </a:pPr>
+                      <a:r>
+                        <a:rPr lang="en-US" sz="1400" dirty="0">
+                          <a:solidFill>
+                            <a:schemeClr val="tx1"/>
+                          </a:solidFill>
+                        </a:rPr>
+                        <a:t>0.809</a:t>
+                      </a:r>
+                      <a:endParaRPr lang="en-US" sz="1400" dirty="0"/>
+                    </a:p>
+                  </a:txBody>
+                  <a:tcPr marL="91440" marR="91440" marT="45720" marB="45720">
+                    <a:lnL w="6350" cap="flat" cmpd="sng" algn="ctr">
+                      <a:solidFill>
+                        <a:srgbClr val="DDE5E4"/>
+                      </a:solidFill>
+                      <a:prstDash val="solid"/>
+                      <a:round/>
+                      <a:headEnd type="none" w="med" len="med"/>
+                      <a:tailEnd type="none" w="med" len="med"/>
+                    </a:lnL>
+                    <a:lnR w="6350" cap="flat" cmpd="sng" algn="ctr">
+                      <a:solidFill>
+                        <a:srgbClr val="DDE5E4"/>
+                      </a:solidFill>
+                      <a:prstDash val="solid"/>
+                      <a:round/>
+                      <a:headEnd type="none" w="med" len="med"/>
+                      <a:tailEnd type="none" w="med" len="med"/>
+                    </a:lnR>
+                    <a:lnT w="6350" cap="flat" cmpd="sng" algn="ctr">
+                      <a:solidFill>
+                        <a:srgbClr val="DDE5E4"/>
+                      </a:solidFill>
+                      <a:prstDash val="solid"/>
+                      <a:round/>
+                      <a:headEnd type="none" w="med" len="med"/>
+                      <a:tailEnd type="none" w="med" len="med"/>
+                    </a:lnT>
+                    <a:lnB w="6350" cap="flat" cmpd="sng" algn="ctr">
+                      <a:solidFill>
+                        <a:srgbClr val="DDE5E4"/>
+                      </a:solidFill>
+                      <a:prstDash val="solid"/>
+                      <a:round/>
+                      <a:headEnd type="none" w="med" len="med"/>
+                      <a:tailEnd type="none" w="med" len="med"/>
+                    </a:lnB>
+                    <a:solidFill>
+                      <a:schemeClr val="bg1"/>
+                    </a:solidFill>
+                  </a:tcPr>
+                </a:tc>
+                <a:tc>
+                  <a:txBody>
+                    <a:bodyPr/>
+                    <a:lstStyle/>
+                    <a:p>
+                      <a:pPr indent="0" marL="0">
+                        <a:buNone/>
+                      </a:pPr>
+                      <a:r>
+                        <a:rPr lang="en-US" sz="1400" dirty="0">
+                          <a:solidFill>
+                            <a:schemeClr val="tx1"/>
+                          </a:solidFill>
+                        </a:rPr>
+                        <a:t>+0.022</a:t>
+                      </a:r>
+                      <a:endParaRPr lang="en-US" sz="1400" dirty="0"/>
+                    </a:p>
+                  </a:txBody>
+                  <a:tcPr marL="91440" marR="91440" marT="45720" marB="45720">
+                    <a:lnL w="6350" cap="flat" cmpd="sng" algn="ctr">
+                      <a:solidFill>
+                        <a:srgbClr val="DDE5E4"/>
+                      </a:solidFill>
+                      <a:prstDash val="solid"/>
+                      <a:round/>
+                      <a:headEnd type="none" w="med" len="med"/>
+                      <a:tailEnd type="none" w="med" len="med"/>
+                    </a:lnL>
+                    <a:lnR w="6350" cap="flat" cmpd="sng" algn="ctr">
+                      <a:solidFill>
+                        <a:srgbClr val="DDE5E4"/>
+                      </a:solidFill>
+                      <a:prstDash val="solid"/>
+                      <a:round/>
+                      <a:headEnd type="none" w="med" len="med"/>
+                      <a:tailEnd type="none" w="med" len="med"/>
+                    </a:lnR>
+                    <a:lnT w="6350" cap="flat" cmpd="sng" algn="ctr">
+                      <a:solidFill>
+                        <a:srgbClr val="DDE5E4"/>
+                      </a:solidFill>
+                      <a:prstDash val="solid"/>
+                      <a:round/>
+                      <a:headEnd type="none" w="med" len="med"/>
+                      <a:tailEnd type="none" w="med" len="med"/>
+                    </a:lnT>
+                    <a:lnB w="6350" cap="flat" cmpd="sng" algn="ctr">
+                      <a:solidFill>
+                        <a:srgbClr val="DDE5E4"/>
+                      </a:solidFill>
+                      <a:prstDash val="solid"/>
+                      <a:round/>
+                      <a:headEnd type="none" w="med" len="med"/>
+                      <a:tailEnd type="none" w="med" len="med"/>
+                    </a:lnB>
+                    <a:solidFill>
+                      <a:schemeClr val="bg1"/>
+                    </a:solidFill>
+                  </a:tcPr>
+                </a:tc>
+              </a:tr>
+              <a:tr h="384048">
+                <a:tc>
+                  <a:txBody>
+                    <a:bodyPr/>
+                    <a:lstStyle/>
+                    <a:p>
+                      <a:pPr indent="0" marL="0">
+                        <a:buNone/>
+                      </a:pPr>
+                      <a:r>
+                        <a:rPr lang="en-US" sz="1400" dirty="0">
+                          <a:solidFill>
+                            <a:schemeClr val="tx1"/>
+                          </a:solidFill>
+                        </a:rPr>
+                        <a:t>Inbar3, Inbar12, inbar1, Inbar9 (hardest)</a:t>
+                      </a:r>
+                      <a:endParaRPr lang="en-US" sz="1400" dirty="0"/>
+                    </a:p>
+                  </a:txBody>
+                  <a:tcPr marL="91440" marR="91440" marT="45720" marB="45720">
+                    <a:lnL w="6350" cap="flat" cmpd="sng" algn="ctr">
+                      <a:solidFill>
+                        <a:srgbClr val="DDE5E4"/>
+                      </a:solidFill>
+                      <a:prstDash val="solid"/>
+                      <a:round/>
+                      <a:headEnd type="none" w="med" len="med"/>
+                      <a:tailEnd type="none" w="med" len="med"/>
+                    </a:lnL>
+                    <a:lnR w="6350" cap="flat" cmpd="sng" algn="ctr">
+                      <a:solidFill>
+                        <a:srgbClr val="DDE5E4"/>
+                      </a:solidFill>
+                      <a:prstDash val="solid"/>
+                      <a:round/>
+                      <a:headEnd type="none" w="med" len="med"/>
+                      <a:tailEnd type="none" w="med" len="med"/>
+                    </a:lnR>
+                    <a:lnT w="6350" cap="flat" cmpd="sng" algn="ctr">
+                      <a:solidFill>
+                        <a:srgbClr val="DDE5E4"/>
+                      </a:solidFill>
+                      <a:prstDash val="solid"/>
+                      <a:round/>
+                      <a:headEnd type="none" w="med" len="med"/>
+                      <a:tailEnd type="none" w="med" len="med"/>
+                    </a:lnT>
+                    <a:lnB w="6350" cap="flat" cmpd="sng" algn="ctr">
+                      <a:solidFill>
+                        <a:srgbClr val="DDE5E4"/>
+                      </a:solidFill>
+                      <a:prstDash val="solid"/>
+                      <a:round/>
+                      <a:headEnd type="none" w="med" len="med"/>
+                      <a:tailEnd type="none" w="med" len="med"/>
+                    </a:lnB>
+                    <a:solidFill>
+                      <a:schemeClr val="bg1"/>
+                    </a:solidFill>
+                  </a:tcPr>
+                </a:tc>
+                <a:tc>
+                  <a:txBody>
+                    <a:bodyPr/>
+                    <a:lstStyle/>
+                    <a:p>
+                      <a:pPr indent="0" marL="0">
+                        <a:buNone/>
+                      </a:pPr>
+                      <a:r>
+                        <a:rPr lang="en-US" sz="1400" dirty="0">
+                          <a:solidFill>
+                            <a:schemeClr val="tx1"/>
+                          </a:solidFill>
+                        </a:rPr>
+                        <a:t>0.741</a:t>
+                      </a:r>
+                      <a:endParaRPr lang="en-US" sz="1400" dirty="0"/>
+                    </a:p>
+                  </a:txBody>
+                  <a:tcPr marL="91440" marR="91440" marT="45720" marB="45720">
+                    <a:lnL w="6350" cap="flat" cmpd="sng" algn="ctr">
+                      <a:solidFill>
+                        <a:srgbClr val="DDE5E4"/>
+                      </a:solidFill>
+                      <a:prstDash val="solid"/>
+                      <a:round/>
+                      <a:headEnd type="none" w="med" len="med"/>
+                      <a:tailEnd type="none" w="med" len="med"/>
+                    </a:lnL>
+                    <a:lnR w="6350" cap="flat" cmpd="sng" algn="ctr">
+                      <a:solidFill>
+                        <a:srgbClr val="DDE5E4"/>
+                      </a:solidFill>
+                      <a:prstDash val="solid"/>
+                      <a:round/>
+                      <a:headEnd type="none" w="med" len="med"/>
+                      <a:tailEnd type="none" w="med" len="med"/>
+                    </a:lnR>
+                    <a:lnT w="6350" cap="flat" cmpd="sng" algn="ctr">
+                      <a:solidFill>
+                        <a:srgbClr val="DDE5E4"/>
+                      </a:solidFill>
+                      <a:prstDash val="solid"/>
+                      <a:round/>
+                      <a:headEnd type="none" w="med" len="med"/>
+                      <a:tailEnd type="none" w="med" len="med"/>
+                    </a:lnT>
+                    <a:lnB w="6350" cap="flat" cmpd="sng" algn="ctr">
+                      <a:solidFill>
+                        <a:srgbClr val="DDE5E4"/>
+                      </a:solidFill>
+                      <a:prstDash val="solid"/>
+                      <a:round/>
+                      <a:headEnd type="none" w="med" len="med"/>
+                      <a:tailEnd type="none" w="med" len="med"/>
+                    </a:lnB>
+                    <a:solidFill>
+                      <a:schemeClr val="bg1"/>
+                    </a:solidFill>
+                  </a:tcPr>
+                </a:tc>
+                <a:tc>
+                  <a:txBody>
+                    <a:bodyPr/>
+                    <a:lstStyle/>
+                    <a:p>
+                      <a:pPr indent="0" marL="0">
+                        <a:buNone/>
+                      </a:pPr>
+                      <a:r>
+                        <a:rPr lang="en-US" sz="1400" b="1" dirty="0">
+                          <a:solidFill>
+                            <a:schemeClr val="tx1"/>
+                          </a:solidFill>
+                        </a:rPr>
+                        <a:t>0.782</a:t>
+                      </a:r>
+                      <a:endParaRPr lang="en-US" sz="1400" dirty="0"/>
+                    </a:p>
+                  </a:txBody>
+                  <a:tcPr marL="91440" marR="91440" marT="45720" marB="45720">
+                    <a:lnL w="6350" cap="flat" cmpd="sng" algn="ctr">
+                      <a:solidFill>
+                        <a:srgbClr val="DDE5E4"/>
+                      </a:solidFill>
+                      <a:prstDash val="solid"/>
+                      <a:round/>
+                      <a:headEnd type="none" w="med" len="med"/>
+                      <a:tailEnd type="none" w="med" len="med"/>
+                    </a:lnL>
+                    <a:lnR w="6350" cap="flat" cmpd="sng" algn="ctr">
+                      <a:solidFill>
+                        <a:srgbClr val="DDE5E4"/>
+                      </a:solidFill>
+                      <a:prstDash val="solid"/>
+                      <a:round/>
+                      <a:headEnd type="none" w="med" len="med"/>
+                      <a:tailEnd type="none" w="med" len="med"/>
+                    </a:lnR>
+                    <a:lnT w="6350" cap="flat" cmpd="sng" algn="ctr">
+                      <a:solidFill>
+                        <a:srgbClr val="DDE5E4"/>
+                      </a:solidFill>
+                      <a:prstDash val="solid"/>
+                      <a:round/>
+                      <a:headEnd type="none" w="med" len="med"/>
+                      <a:tailEnd type="none" w="med" len="med"/>
+                    </a:lnT>
+                    <a:lnB w="6350" cap="flat" cmpd="sng" algn="ctr">
+                      <a:solidFill>
+                        <a:srgbClr val="DDE5E4"/>
+                      </a:solidFill>
+                      <a:prstDash val="solid"/>
+                      <a:round/>
+                      <a:headEnd type="none" w="med" len="med"/>
+                      <a:tailEnd type="none" w="med" len="med"/>
+                    </a:lnB>
+                    <a:solidFill>
+                      <a:schemeClr val="bg1"/>
+                    </a:solidFill>
+                  </a:tcPr>
+                </a:tc>
+                <a:tc>
+                  <a:txBody>
+                    <a:bodyPr/>
+                    <a:lstStyle/>
+                    <a:p>
+                      <a:pPr indent="0" marL="0">
+                        <a:buNone/>
+                      </a:pPr>
+                      <a:r>
+                        <a:rPr lang="en-US" sz="1400" dirty="0">
+                          <a:solidFill>
+                            <a:schemeClr val="tx1"/>
+                          </a:solidFill>
+                        </a:rPr>
+                        <a:t>+0.041</a:t>
+                      </a:r>
+                      <a:endParaRPr lang="en-US" sz="1400" dirty="0"/>
+                    </a:p>
+                  </a:txBody>
+                  <a:tcPr marL="91440" marR="91440" marT="45720" marB="45720">
+                    <a:lnL w="6350" cap="flat" cmpd="sng" algn="ctr">
+                      <a:solidFill>
+                        <a:srgbClr val="DDE5E4"/>
+                      </a:solidFill>
+                      <a:prstDash val="solid"/>
+                      <a:round/>
+                      <a:headEnd type="none" w="med" len="med"/>
+                      <a:tailEnd type="none" w="med" len="med"/>
+                    </a:lnL>
+                    <a:lnR w="6350" cap="flat" cmpd="sng" algn="ctr">
+                      <a:solidFill>
+                        <a:srgbClr val="DDE5E4"/>
+                      </a:solidFill>
+                      <a:prstDash val="solid"/>
+                      <a:round/>
+                      <a:headEnd type="none" w="med" len="med"/>
+                      <a:tailEnd type="none" w="med" len="med"/>
+                    </a:lnR>
+                    <a:lnT w="6350" cap="flat" cmpd="sng" algn="ctr">
+                      <a:solidFill>
+                        <a:srgbClr val="DDE5E4"/>
+                      </a:solidFill>
+                      <a:prstDash val="solid"/>
+                      <a:round/>
+                      <a:headEnd type="none" w="med" len="med"/>
+                      <a:tailEnd type="none" w="med" len="med"/>
+                    </a:lnT>
+                    <a:lnB w="6350" cap="flat" cmpd="sng" algn="ctr">
+                      <a:solidFill>
+                        <a:srgbClr val="DDE5E4"/>
+                      </a:solidFill>
+                      <a:prstDash val="solid"/>
+                      <a:round/>
+                      <a:headEnd type="none" w="med" len="med"/>
+                      <a:tailEnd type="none" w="med" len="med"/>
+                    </a:lnB>
+                    <a:solidFill>
+                      <a:schemeClr val="bg1"/>
+                    </a:solidFill>
+                  </a:tcPr>
+                </a:tc>
+              </a:tr>
+              <a:tr h="384048">
+                <a:tc>
+                  <a:txBody>
+                    <a:bodyPr/>
+                    <a:lstStyle/>
+                    <a:p>
+                      <a:pPr indent="0" marL="0">
+                        <a:buNone/>
+                      </a:pPr>
+                      <a:r>
+                        <a:rPr lang="en-US" sz="1400" dirty="0">
+                          <a:solidFill>
+                            <a:schemeClr val="tx1"/>
+                          </a:solidFill>
+                        </a:rPr>
+                        <a:t>Inbar9, inbar4, Inbar8, Inbar11</a:t>
+                      </a:r>
+                      <a:endParaRPr lang="en-US" sz="1400" dirty="0"/>
+                    </a:p>
+                  </a:txBody>
+                  <a:tcPr marL="91440" marR="91440" marT="45720" marB="45720">
+                    <a:lnL w="6350" cap="flat" cmpd="sng" algn="ctr">
+                      <a:solidFill>
+                        <a:srgbClr val="DDE5E4"/>
+                      </a:solidFill>
+                      <a:prstDash val="solid"/>
+                      <a:round/>
+                      <a:headEnd type="none" w="med" len="med"/>
+                      <a:tailEnd type="none" w="med" len="med"/>
+                    </a:lnL>
+                    <a:lnR w="6350" cap="flat" cmpd="sng" algn="ctr">
+                      <a:solidFill>
+                        <a:srgbClr val="DDE5E4"/>
+                      </a:solidFill>
+                      <a:prstDash val="solid"/>
+                      <a:round/>
+                      <a:headEnd type="none" w="med" len="med"/>
+                      <a:tailEnd type="none" w="med" len="med"/>
+                    </a:lnR>
+                    <a:lnT w="6350" cap="flat" cmpd="sng" algn="ctr">
+                      <a:solidFill>
+                        <a:srgbClr val="DDE5E4"/>
+                      </a:solidFill>
+                      <a:prstDash val="solid"/>
+                      <a:round/>
+                      <a:headEnd type="none" w="med" len="med"/>
+                      <a:tailEnd type="none" w="med" len="med"/>
+                    </a:lnT>
+                    <a:lnB w="6350" cap="flat" cmpd="sng" algn="ctr">
+                      <a:solidFill>
+                        <a:srgbClr val="DDE5E4"/>
+                      </a:solidFill>
+                      <a:prstDash val="solid"/>
+                      <a:round/>
+                      <a:headEnd type="none" w="med" len="med"/>
+                      <a:tailEnd type="none" w="med" len="med"/>
+                    </a:lnB>
+                    <a:solidFill>
+                      <a:schemeClr val="bg1"/>
+                    </a:solidFill>
+                  </a:tcPr>
+                </a:tc>
+                <a:tc>
+                  <a:txBody>
+                    <a:bodyPr/>
+                    <a:lstStyle/>
+                    <a:p>
+                      <a:pPr indent="0" marL="0">
+                        <a:buNone/>
+                      </a:pPr>
+                      <a:r>
+                        <a:rPr lang="en-US" sz="1400" b="1" dirty="0">
+                          <a:solidFill>
+                            <a:schemeClr val="tx1"/>
+                          </a:solidFill>
+                        </a:rPr>
+                        <a:t>0.838</a:t>
+                      </a:r>
+                      <a:endParaRPr lang="en-US" sz="1400" dirty="0"/>
+                    </a:p>
+                  </a:txBody>
+                  <a:tcPr marL="91440" marR="91440" marT="45720" marB="45720">
+                    <a:lnL w="6350" cap="flat" cmpd="sng" algn="ctr">
+                      <a:solidFill>
+                        <a:srgbClr val="DDE5E4"/>
+                      </a:solidFill>
+                      <a:prstDash val="solid"/>
+                      <a:round/>
+                      <a:headEnd type="none" w="med" len="med"/>
+                      <a:tailEnd type="none" w="med" len="med"/>
+                    </a:lnL>
+                    <a:lnR w="6350" cap="flat" cmpd="sng" algn="ctr">
+                      <a:solidFill>
+                        <a:srgbClr val="DDE5E4"/>
+                      </a:solidFill>
+                      <a:prstDash val="solid"/>
+                      <a:round/>
+                      <a:headEnd type="none" w="med" len="med"/>
+                      <a:tailEnd type="none" w="med" len="med"/>
+                    </a:lnR>
+                    <a:lnT w="6350" cap="flat" cmpd="sng" algn="ctr">
+                      <a:solidFill>
+                        <a:srgbClr val="DDE5E4"/>
+                      </a:solidFill>
+                      <a:prstDash val="solid"/>
+                      <a:round/>
+                      <a:headEnd type="none" w="med" len="med"/>
+                      <a:tailEnd type="none" w="med" len="med"/>
+                    </a:lnT>
+                    <a:lnB w="6350" cap="flat" cmpd="sng" algn="ctr">
+                      <a:solidFill>
+                        <a:srgbClr val="DDE5E4"/>
+                      </a:solidFill>
+                      <a:prstDash val="solid"/>
+                      <a:round/>
+                      <a:headEnd type="none" w="med" len="med"/>
+                      <a:tailEnd type="none" w="med" len="med"/>
+                    </a:lnB>
+                    <a:solidFill>
+                      <a:schemeClr val="bg1"/>
+                    </a:solidFill>
+                  </a:tcPr>
+                </a:tc>
+                <a:tc>
+                  <a:txBody>
+                    <a:bodyPr/>
+                    <a:lstStyle/>
+                    <a:p>
+                      <a:pPr indent="0" marL="0">
+                        <a:buNone/>
+                      </a:pPr>
+                      <a:r>
+                        <a:rPr lang="en-US" sz="1400" dirty="0">
+                          <a:solidFill>
+                            <a:schemeClr val="tx1"/>
+                          </a:solidFill>
+                        </a:rPr>
+                        <a:t>0.827</a:t>
+                      </a:r>
+                      <a:endParaRPr lang="en-US" sz="1400" dirty="0"/>
+                    </a:p>
+                  </a:txBody>
+                  <a:tcPr marL="91440" marR="91440" marT="45720" marB="45720">
+                    <a:lnL w="6350" cap="flat" cmpd="sng" algn="ctr">
+                      <a:solidFill>
+                        <a:srgbClr val="DDE5E4"/>
+                      </a:solidFill>
+                      <a:prstDash val="solid"/>
+                      <a:round/>
+                      <a:headEnd type="none" w="med" len="med"/>
+                      <a:tailEnd type="none" w="med" len="med"/>
+                    </a:lnL>
+                    <a:lnR w="6350" cap="flat" cmpd="sng" algn="ctr">
+                      <a:solidFill>
+                        <a:srgbClr val="DDE5E4"/>
+                      </a:solidFill>
+                      <a:prstDash val="solid"/>
+                      <a:round/>
+                      <a:headEnd type="none" w="med" len="med"/>
+                      <a:tailEnd type="none" w="med" len="med"/>
+                    </a:lnR>
+                    <a:lnT w="6350" cap="flat" cmpd="sng" algn="ctr">
+                      <a:solidFill>
+                        <a:srgbClr val="DDE5E4"/>
+                      </a:solidFill>
+                      <a:prstDash val="solid"/>
+                      <a:round/>
+                      <a:headEnd type="none" w="med" len="med"/>
+                      <a:tailEnd type="none" w="med" len="med"/>
+                    </a:lnT>
+                    <a:lnB w="6350" cap="flat" cmpd="sng" algn="ctr">
+                      <a:solidFill>
+                        <a:srgbClr val="DDE5E4"/>
+                      </a:solidFill>
+                      <a:prstDash val="solid"/>
+                      <a:round/>
+                      <a:headEnd type="none" w="med" len="med"/>
+                      <a:tailEnd type="none" w="med" len="med"/>
+                    </a:lnB>
+                    <a:solidFill>
+                      <a:schemeClr val="bg1"/>
+                    </a:solidFill>
+                  </a:tcPr>
+                </a:tc>
+                <a:tc>
+                  <a:txBody>
+                    <a:bodyPr/>
+                    <a:lstStyle/>
+                    <a:p>
+                      <a:pPr indent="0" marL="0">
+                        <a:buNone/>
+                      </a:pPr>
+                      <a:r>
+                        <a:rPr lang="en-US" sz="1400" dirty="0">
+                          <a:solidFill>
+                            <a:schemeClr val="tx1"/>
+                          </a:solidFill>
+                        </a:rPr>
+                        <a:t>−0.011</a:t>
+                      </a:r>
+                      <a:endParaRPr lang="en-US" sz="1400" dirty="0"/>
+                    </a:p>
+                  </a:txBody>
+                  <a:tcPr marL="91440" marR="91440" marT="45720" marB="45720">
+                    <a:lnL w="6350" cap="flat" cmpd="sng" algn="ctr">
+                      <a:solidFill>
+                        <a:srgbClr val="DDE5E4"/>
+                      </a:solidFill>
+                      <a:prstDash val="solid"/>
+                      <a:round/>
+                      <a:headEnd type="none" w="med" len="med"/>
+                      <a:tailEnd type="none" w="med" len="med"/>
+                    </a:lnL>
+                    <a:lnR w="6350" cap="flat" cmpd="sng" algn="ctr">
+                      <a:solidFill>
+                        <a:srgbClr val="DDE5E4"/>
+                      </a:solidFill>
+                      <a:prstDash val="solid"/>
+                      <a:round/>
+                      <a:headEnd type="none" w="med" len="med"/>
+                      <a:tailEnd type="none" w="med" len="med"/>
+                    </a:lnR>
+                    <a:lnT w="6350" cap="flat" cmpd="sng" algn="ctr">
+                      <a:solidFill>
+                        <a:srgbClr val="DDE5E4"/>
+                      </a:solidFill>
+                      <a:prstDash val="solid"/>
+                      <a:round/>
+                      <a:headEnd type="none" w="med" len="med"/>
+                      <a:tailEnd type="none" w="med" len="med"/>
+                    </a:lnT>
+                    <a:lnB w="6350" cap="flat" cmpd="sng" algn="ctr">
+                      <a:solidFill>
+                        <a:srgbClr val="DDE5E4"/>
+                      </a:solidFill>
+                      <a:prstDash val="solid"/>
+                      <a:round/>
+                      <a:headEnd type="none" w="med" len="med"/>
+                      <a:tailEnd type="none" w="med" len="med"/>
+                    </a:lnB>
+                    <a:solidFill>
+                      <a:schemeClr val="bg1"/>
+                    </a:solidFill>
+                  </a:tcPr>
+                </a:tc>
+              </a:tr>
+              <a:tr h="384048">
+                <a:tc>
+                  <a:txBody>
+                    <a:bodyPr/>
+                    <a:lstStyle/>
+                    <a:p>
+                      <a:pPr indent="0" marL="0">
+                        <a:buNone/>
+                      </a:pPr>
+                      <a:r>
+                        <a:rPr lang="en-US" sz="1400" dirty="0">
+                          <a:solidFill>
+                            <a:schemeClr val="tx1"/>
+                          </a:solidFill>
+                        </a:rPr>
+                        <a:t>Inbar10, Inbar2, Inbar6, Inbar8</a:t>
+                      </a:r>
+                      <a:endParaRPr lang="en-US" sz="1400" dirty="0"/>
+                    </a:p>
+                  </a:txBody>
+                  <a:tcPr marL="91440" marR="91440" marT="45720" marB="45720">
+                    <a:lnL w="6350" cap="flat" cmpd="sng" algn="ctr">
+                      <a:solidFill>
+                        <a:srgbClr val="DDE5E4"/>
+                      </a:solidFill>
+                      <a:prstDash val="solid"/>
+                      <a:round/>
+                      <a:headEnd type="none" w="med" len="med"/>
+                      <a:tailEnd type="none" w="med" len="med"/>
+                    </a:lnL>
+                    <a:lnR w="6350" cap="flat" cmpd="sng" algn="ctr">
+                      <a:solidFill>
+                        <a:srgbClr val="DDE5E4"/>
+                      </a:solidFill>
+                      <a:prstDash val="solid"/>
+                      <a:round/>
+                      <a:headEnd type="none" w="med" len="med"/>
+                      <a:tailEnd type="none" w="med" len="med"/>
+                    </a:lnR>
+                    <a:lnT w="6350" cap="flat" cmpd="sng" algn="ctr">
+                      <a:solidFill>
+                        <a:srgbClr val="DDE5E4"/>
+                      </a:solidFill>
+                      <a:prstDash val="solid"/>
+                      <a:round/>
+                      <a:headEnd type="none" w="med" len="med"/>
+                      <a:tailEnd type="none" w="med" len="med"/>
+                    </a:lnT>
+                    <a:lnB w="6350" cap="flat" cmpd="sng" algn="ctr">
+                      <a:solidFill>
+                        <a:srgbClr val="DDE5E4"/>
+                      </a:solidFill>
+                      <a:prstDash val="solid"/>
+                      <a:round/>
+                      <a:headEnd type="none" w="med" len="med"/>
+                      <a:tailEnd type="none" w="med" len="med"/>
+                    </a:lnB>
+                    <a:solidFill>
+                      <a:schemeClr val="bg1"/>
+                    </a:solidFill>
+                  </a:tcPr>
+                </a:tc>
+                <a:tc>
+                  <a:txBody>
+                    <a:bodyPr/>
+                    <a:lstStyle/>
+                    <a:p>
+                      <a:pPr indent="0" marL="0">
+                        <a:buNone/>
+                      </a:pPr>
+                      <a:r>
+                        <a:rPr lang="en-US" sz="1400" dirty="0">
+                          <a:solidFill>
+                            <a:schemeClr val="tx1"/>
+                          </a:solidFill>
+                        </a:rPr>
+                        <a:t>0.847</a:t>
+                      </a:r>
+                      <a:endParaRPr lang="en-US" sz="1400" dirty="0"/>
+                    </a:p>
+                  </a:txBody>
+                  <a:tcPr marL="91440" marR="91440" marT="45720" marB="45720">
+                    <a:lnL w="6350" cap="flat" cmpd="sng" algn="ctr">
+                      <a:solidFill>
+                        <a:srgbClr val="DDE5E4"/>
+                      </a:solidFill>
+                      <a:prstDash val="solid"/>
+                      <a:round/>
+                      <a:headEnd type="none" w="med" len="med"/>
+                      <a:tailEnd type="none" w="med" len="med"/>
+                    </a:lnL>
+                    <a:lnR w="6350" cap="flat" cmpd="sng" algn="ctr">
+                      <a:solidFill>
+                        <a:srgbClr val="DDE5E4"/>
+                      </a:solidFill>
+                      <a:prstDash val="solid"/>
+                      <a:round/>
+                      <a:headEnd type="none" w="med" len="med"/>
+                      <a:tailEnd type="none" w="med" len="med"/>
+                    </a:lnR>
+                    <a:lnT w="6350" cap="flat" cmpd="sng" algn="ctr">
+                      <a:solidFill>
+                        <a:srgbClr val="DDE5E4"/>
+                      </a:solidFill>
+                      <a:prstDash val="solid"/>
+                      <a:round/>
+                      <a:headEnd type="none" w="med" len="med"/>
+                      <a:tailEnd type="none" w="med" len="med"/>
+                    </a:lnT>
+                    <a:lnB w="6350" cap="flat" cmpd="sng" algn="ctr">
+                      <a:solidFill>
+                        <a:srgbClr val="DDE5E4"/>
+                      </a:solidFill>
+                      <a:prstDash val="solid"/>
+                      <a:round/>
+                      <a:headEnd type="none" w="med" len="med"/>
+                      <a:tailEnd type="none" w="med" len="med"/>
+                    </a:lnB>
+                    <a:solidFill>
+                      <a:schemeClr val="bg1"/>
+                    </a:solidFill>
+                  </a:tcPr>
+                </a:tc>
+                <a:tc>
+                  <a:txBody>
+                    <a:bodyPr/>
+                    <a:lstStyle/>
+                    <a:p>
+                      <a:pPr indent="0" marL="0">
+                        <a:buNone/>
+                      </a:pPr>
+                      <a:r>
+                        <a:rPr lang="en-US" sz="1400" b="1" dirty="0">
+                          <a:solidFill>
+                            <a:schemeClr val="tx1"/>
+                          </a:solidFill>
+                        </a:rPr>
+                        <a:t>0.848</a:t>
+                      </a:r>
+                      <a:endParaRPr lang="en-US" sz="1400" dirty="0"/>
+                    </a:p>
+                  </a:txBody>
+                  <a:tcPr marL="91440" marR="91440" marT="45720" marB="45720">
+                    <a:lnL w="6350" cap="flat" cmpd="sng" algn="ctr">
+                      <a:solidFill>
+                        <a:srgbClr val="DDE5E4"/>
+                      </a:solidFill>
+                      <a:prstDash val="solid"/>
+                      <a:round/>
+                      <a:headEnd type="none" w="med" len="med"/>
+                      <a:tailEnd type="none" w="med" len="med"/>
+                    </a:lnL>
+                    <a:lnR w="6350" cap="flat" cmpd="sng" algn="ctr">
+                      <a:solidFill>
+                        <a:srgbClr val="DDE5E4"/>
+                      </a:solidFill>
+                      <a:prstDash val="solid"/>
+                      <a:round/>
+                      <a:headEnd type="none" w="med" len="med"/>
+                      <a:tailEnd type="none" w="med" len="med"/>
+                    </a:lnR>
+                    <a:lnT w="6350" cap="flat" cmpd="sng" algn="ctr">
+                      <a:solidFill>
+                        <a:srgbClr val="DDE5E4"/>
+                      </a:solidFill>
+                      <a:prstDash val="solid"/>
+                      <a:round/>
+                      <a:headEnd type="none" w="med" len="med"/>
+                      <a:tailEnd type="none" w="med" len="med"/>
+                    </a:lnT>
+                    <a:lnB w="6350" cap="flat" cmpd="sng" algn="ctr">
+                      <a:solidFill>
+                        <a:srgbClr val="DDE5E4"/>
+                      </a:solidFill>
+                      <a:prstDash val="solid"/>
+                      <a:round/>
+                      <a:headEnd type="none" w="med" len="med"/>
+                      <a:tailEnd type="none" w="med" len="med"/>
+                    </a:lnB>
+                    <a:solidFill>
+                      <a:schemeClr val="bg1"/>
+                    </a:solidFill>
+                  </a:tcPr>
+                </a:tc>
+                <a:tc>
+                  <a:txBody>
+                    <a:bodyPr/>
+                    <a:lstStyle/>
+                    <a:p>
+                      <a:pPr indent="0" marL="0">
+                        <a:buNone/>
+                      </a:pPr>
+                      <a:r>
+                        <a:rPr lang="en-US" sz="1400" dirty="0">
+                          <a:solidFill>
+                            <a:schemeClr val="tx1"/>
+                          </a:solidFill>
+                        </a:rPr>
+                        <a:t>+0.001</a:t>
+                      </a:r>
+                      <a:endParaRPr lang="en-US" sz="1400" dirty="0"/>
+                    </a:p>
+                  </a:txBody>
+                  <a:tcPr marL="91440" marR="91440" marT="45720" marB="45720">
+                    <a:lnL w="6350" cap="flat" cmpd="sng" algn="ctr">
+                      <a:solidFill>
+                        <a:srgbClr val="DDE5E4"/>
+                      </a:solidFill>
+                      <a:prstDash val="solid"/>
+                      <a:round/>
+                      <a:headEnd type="none" w="med" len="med"/>
+                      <a:tailEnd type="none" w="med" len="med"/>
+                    </a:lnL>
+                    <a:lnR w="6350" cap="flat" cmpd="sng" algn="ctr">
+                      <a:solidFill>
+                        <a:srgbClr val="DDE5E4"/>
+                      </a:solidFill>
+                      <a:prstDash val="solid"/>
+                      <a:round/>
+                      <a:headEnd type="none" w="med" len="med"/>
+                      <a:tailEnd type="none" w="med" len="med"/>
+                    </a:lnR>
+                    <a:lnT w="6350" cap="flat" cmpd="sng" algn="ctr">
+                      <a:solidFill>
+                        <a:srgbClr val="DDE5E4"/>
+                      </a:solidFill>
+                      <a:prstDash val="solid"/>
+                      <a:round/>
+                      <a:headEnd type="none" w="med" len="med"/>
+                      <a:tailEnd type="none" w="med" len="med"/>
+                    </a:lnT>
+                    <a:lnB w="6350" cap="flat" cmpd="sng" algn="ctr">
+                      <a:solidFill>
+                        <a:srgbClr val="DDE5E4"/>
+                      </a:solidFill>
+                      <a:prstDash val="solid"/>
+                      <a:round/>
+                      <a:headEnd type="none" w="med" len="med"/>
+                      <a:tailEnd type="none" w="med" len="med"/>
+                    </a:lnB>
+                    <a:solidFill>
+                      <a:schemeClr val="bg1"/>
+                    </a:solidFill>
+                  </a:tcPr>
+                </a:tc>
+              </a:tr>
+              <a:tr h="384048">
+                <a:tc>
+                  <a:txBody>
+                    <a:bodyPr/>
+                    <a:lstStyle/>
+                    <a:p>
+                      <a:pPr indent="0" marL="0">
+                        <a:buNone/>
+                      </a:pPr>
+                      <a:r>
+                        <a:rPr lang="en-US" sz="1400" dirty="0">
+                          <a:solidFill>
+                            <a:schemeClr val="tx1"/>
+                          </a:solidFill>
+                        </a:rPr>
+                        <a:t>Inbar12, Inbar2, Inbar11, inbar4</a:t>
+                      </a:r>
+                      <a:endParaRPr lang="en-US" sz="1400" dirty="0"/>
+                    </a:p>
+                  </a:txBody>
+                  <a:tcPr marL="91440" marR="91440" marT="45720" marB="45720">
+                    <a:lnL w="6350" cap="flat" cmpd="sng" algn="ctr">
+                      <a:solidFill>
+                        <a:srgbClr val="DDE5E4"/>
+                      </a:solidFill>
+                      <a:prstDash val="solid"/>
+                      <a:round/>
+                      <a:headEnd type="none" w="med" len="med"/>
+                      <a:tailEnd type="none" w="med" len="med"/>
+                    </a:lnL>
+                    <a:lnR w="6350" cap="flat" cmpd="sng" algn="ctr">
+                      <a:solidFill>
+                        <a:srgbClr val="DDE5E4"/>
+                      </a:solidFill>
+                      <a:prstDash val="solid"/>
+                      <a:round/>
+                      <a:headEnd type="none" w="med" len="med"/>
+                      <a:tailEnd type="none" w="med" len="med"/>
+                    </a:lnR>
+                    <a:lnT w="6350" cap="flat" cmpd="sng" algn="ctr">
+                      <a:solidFill>
+                        <a:srgbClr val="DDE5E4"/>
+                      </a:solidFill>
+                      <a:prstDash val="solid"/>
+                      <a:round/>
+                      <a:headEnd type="none" w="med" len="med"/>
+                      <a:tailEnd type="none" w="med" len="med"/>
+                    </a:lnT>
+                    <a:lnB w="6350" cap="flat" cmpd="sng" algn="ctr">
+                      <a:solidFill>
+                        <a:srgbClr val="DDE5E4"/>
+                      </a:solidFill>
+                      <a:prstDash val="solid"/>
+                      <a:round/>
+                      <a:headEnd type="none" w="med" len="med"/>
+                      <a:tailEnd type="none" w="med" len="med"/>
+                    </a:lnB>
+                    <a:solidFill>
+                      <a:schemeClr val="bg1"/>
+                    </a:solidFill>
+                  </a:tcPr>
+                </a:tc>
+                <a:tc>
+                  <a:txBody>
+                    <a:bodyPr/>
+                    <a:lstStyle/>
+                    <a:p>
+                      <a:pPr indent="0" marL="0">
+                        <a:buNone/>
+                      </a:pPr>
+                      <a:r>
+                        <a:rPr lang="en-US" sz="1400" b="1" dirty="0">
+                          <a:solidFill>
+                            <a:schemeClr val="tx1"/>
+                          </a:solidFill>
+                        </a:rPr>
+                        <a:t>0.826</a:t>
+                      </a:r>
+                      <a:endParaRPr lang="en-US" sz="1400" dirty="0"/>
+                    </a:p>
+                  </a:txBody>
+                  <a:tcPr marL="91440" marR="91440" marT="45720" marB="45720">
+                    <a:lnL w="6350" cap="flat" cmpd="sng" algn="ctr">
+                      <a:solidFill>
+                        <a:srgbClr val="DDE5E4"/>
+                      </a:solidFill>
+                      <a:prstDash val="solid"/>
+                      <a:round/>
+                      <a:headEnd type="none" w="med" len="med"/>
+                      <a:tailEnd type="none" w="med" len="med"/>
+                    </a:lnL>
+                    <a:lnR w="6350" cap="flat" cmpd="sng" algn="ctr">
+                      <a:solidFill>
+                        <a:srgbClr val="DDE5E4"/>
+                      </a:solidFill>
+                      <a:prstDash val="solid"/>
+                      <a:round/>
+                      <a:headEnd type="none" w="med" len="med"/>
+                      <a:tailEnd type="none" w="med" len="med"/>
+                    </a:lnR>
+                    <a:lnT w="6350" cap="flat" cmpd="sng" algn="ctr">
+                      <a:solidFill>
+                        <a:srgbClr val="DDE5E4"/>
+                      </a:solidFill>
+                      <a:prstDash val="solid"/>
+                      <a:round/>
+                      <a:headEnd type="none" w="med" len="med"/>
+                      <a:tailEnd type="none" w="med" len="med"/>
+                    </a:lnT>
+                    <a:lnB w="6350" cap="flat" cmpd="sng" algn="ctr">
+                      <a:solidFill>
+                        <a:srgbClr val="DDE5E4"/>
+                      </a:solidFill>
+                      <a:prstDash val="solid"/>
+                      <a:round/>
+                      <a:headEnd type="none" w="med" len="med"/>
+                      <a:tailEnd type="none" w="med" len="med"/>
+                    </a:lnB>
+                    <a:solidFill>
+                      <a:schemeClr val="bg1"/>
+                    </a:solidFill>
+                  </a:tcPr>
+                </a:tc>
+                <a:tc>
+                  <a:txBody>
+                    <a:bodyPr/>
+                    <a:lstStyle/>
+                    <a:p>
+                      <a:pPr indent="0" marL="0">
+                        <a:buNone/>
+                      </a:pPr>
+                      <a:r>
+                        <a:rPr lang="en-US" sz="1400" dirty="0">
+                          <a:solidFill>
+                            <a:schemeClr val="tx1"/>
+                          </a:solidFill>
+                        </a:rPr>
+                        <a:t>0.817</a:t>
+                      </a:r>
+                      <a:endParaRPr lang="en-US" sz="1400" dirty="0"/>
+                    </a:p>
+                  </a:txBody>
+                  <a:tcPr marL="91440" marR="91440" marT="45720" marB="45720">
+                    <a:lnL w="6350" cap="flat" cmpd="sng" algn="ctr">
+                      <a:solidFill>
+                        <a:srgbClr val="DDE5E4"/>
+                      </a:solidFill>
+                      <a:prstDash val="solid"/>
+                      <a:round/>
+                      <a:headEnd type="none" w="med" len="med"/>
+                      <a:tailEnd type="none" w="med" len="med"/>
+                    </a:lnL>
+                    <a:lnR w="6350" cap="flat" cmpd="sng" algn="ctr">
+                      <a:solidFill>
+                        <a:srgbClr val="DDE5E4"/>
+                      </a:solidFill>
+                      <a:prstDash val="solid"/>
+                      <a:round/>
+                      <a:headEnd type="none" w="med" len="med"/>
+                      <a:tailEnd type="none" w="med" len="med"/>
+                    </a:lnR>
+                    <a:lnT w="6350" cap="flat" cmpd="sng" algn="ctr">
+                      <a:solidFill>
+                        <a:srgbClr val="DDE5E4"/>
+                      </a:solidFill>
+                      <a:prstDash val="solid"/>
+                      <a:round/>
+                      <a:headEnd type="none" w="med" len="med"/>
+                      <a:tailEnd type="none" w="med" len="med"/>
+                    </a:lnT>
+                    <a:lnB w="6350" cap="flat" cmpd="sng" algn="ctr">
+                      <a:solidFill>
+                        <a:srgbClr val="DDE5E4"/>
+                      </a:solidFill>
+                      <a:prstDash val="solid"/>
+                      <a:round/>
+                      <a:headEnd type="none" w="med" len="med"/>
+                      <a:tailEnd type="none" w="med" len="med"/>
+                    </a:lnB>
+                    <a:solidFill>
+                      <a:schemeClr val="bg1"/>
+                    </a:solidFill>
+                  </a:tcPr>
+                </a:tc>
+                <a:tc>
+                  <a:txBody>
+                    <a:bodyPr/>
+                    <a:lstStyle/>
+                    <a:p>
+                      <a:pPr indent="0" marL="0">
+                        <a:buNone/>
+                      </a:pPr>
+                      <a:r>
+                        <a:rPr lang="en-US" sz="1400" dirty="0">
+                          <a:solidFill>
+                            <a:schemeClr val="tx1"/>
+                          </a:solidFill>
+                        </a:rPr>
+                        <a:t>−0.009</a:t>
+                      </a:r>
+                      <a:endParaRPr lang="en-US" sz="1400" dirty="0"/>
+                    </a:p>
+                  </a:txBody>
+                  <a:tcPr marL="91440" marR="91440" marT="45720" marB="45720">
+                    <a:lnL w="6350" cap="flat" cmpd="sng" algn="ctr">
+                      <a:solidFill>
+                        <a:srgbClr val="DDE5E4"/>
+                      </a:solidFill>
+                      <a:prstDash val="solid"/>
+                      <a:round/>
+                      <a:headEnd type="none" w="med" len="med"/>
+                      <a:tailEnd type="none" w="med" len="med"/>
+                    </a:lnL>
+                    <a:lnR w="6350" cap="flat" cmpd="sng" algn="ctr">
+                      <a:solidFill>
+                        <a:srgbClr val="DDE5E4"/>
+                      </a:solidFill>
+                      <a:prstDash val="solid"/>
+                      <a:round/>
+                      <a:headEnd type="none" w="med" len="med"/>
+                      <a:tailEnd type="none" w="med" len="med"/>
+                    </a:lnR>
+                    <a:lnT w="6350" cap="flat" cmpd="sng" algn="ctr">
+                      <a:solidFill>
+                        <a:srgbClr val="DDE5E4"/>
+                      </a:solidFill>
+                      <a:prstDash val="solid"/>
+                      <a:round/>
+                      <a:headEnd type="none" w="med" len="med"/>
+                      <a:tailEnd type="none" w="med" len="med"/>
+                    </a:lnT>
+                    <a:lnB w="6350" cap="flat" cmpd="sng" algn="ctr">
+                      <a:solidFill>
+                        <a:srgbClr val="DDE5E4"/>
+                      </a:solidFill>
+                      <a:prstDash val="solid"/>
+                      <a:round/>
+                      <a:headEnd type="none" w="med" len="med"/>
+                      <a:tailEnd type="none" w="med" len="med"/>
+                    </a:lnB>
+                    <a:solidFill>
+                      <a:schemeClr val="bg1"/>
+                    </a:solidFill>
+                  </a:tcPr>
+                </a:tc>
+              </a:tr>
+            </a:tbl>
+          </a:graphicData>
+        </a:graphic>
+      </p:graphicFrame>
+      <p:sp>
+        <p:nvSpPr>
+          <p:cNvPr id="4" name="mixing caption"/>
+          <p:cNvSpPr txBox="1"/>
+          <p:nvPr/>
+        </p:nvSpPr>
+        <p:spPr>
+          <a:xfrm>
+            <a:off x="548640" y="4983480"/>
+            <a:ext cx="11094415" cy="548640"/>
+          </a:xfrm>
+          <a:prstGeom prst="rect">
+            <a:avLst/>
+          </a:prstGeom>
+          <a:noFill/>
+          <a:ln/>
+        </p:spPr>
+        <p:txBody>
+          <a:bodyPr wrap="square" lIns="0" tIns="0" rIns="0" bIns="0" rtlCol="0" anchor="t"/>
+          <a:lstStyle/>
+          <a:p>
+            <a:pPr indent="0" marL="0">
+              <a:buNone/>
+            </a:pPr>
+            <a:r>
+              <a:rPr lang="en-US" sz="1500" b="1" dirty="0">
+                <a:solidFill>
+                  <a:schemeClr val="tx2"/>
+                </a:solidFill>
+              </a:rPr>
+              <a:t>Mixing both labs lands in between: </a:t>
+            </a:r>
+            <a:pPr indent="0" marL="0">
+              <a:buNone/>
+            </a:pPr>
+            <a:r>
+              <a:rPr lang="en-US" sz="1500" dirty="0">
+                <a:solidFill>
+                  <a:schemeClr val="tx1"/>
+                </a:solidFill>
+              </a:rPr>
+              <a:t>0.821–0.832 on the hard Stav set and 0.767 on the hard Inbar set, where weighting the labs equally helps on Stav but not on Inbar.</a:t>
+            </a:r>
+            <a:endParaRPr lang="en-US" sz="1500" dirty="0"/>
+          </a:p>
+        </p:txBody>
+      </p:sp>
+      <p:sp>
+        <p:nvSpPr>
+          <p:cNvPr id="5" name="confound caveat"/>
+          <p:cNvSpPr txBox="1"/>
+          <p:nvPr/>
+        </p:nvSpPr>
+        <p:spPr>
+          <a:xfrm>
+            <a:off x="548640" y="5623560"/>
+            <a:ext cx="11094415" cy="594360"/>
+          </a:xfrm>
+          <a:prstGeom prst="rect">
+            <a:avLst/>
+          </a:prstGeom>
+          <a:noFill/>
+          <a:ln/>
+        </p:spPr>
+        <p:txBody>
+          <a:bodyPr wrap="square" lIns="0" tIns="0" rIns="0" bIns="0" rtlCol="0" anchor="t"/>
+          <a:lstStyle/>
+          <a:p>
+            <a:pPr indent="0" marL="0">
+              <a:buNone/>
+            </a:pPr>
+            <a:r>
+              <a:rPr lang="en-US" sz="1400" i="1" dirty="0">
+                <a:solidFill>
+                  <a:schemeClr val="accent4"/>
+                </a:solidFill>
+              </a:rPr>
+              <a:t>Caveat: lab and labeller are the same variable here (different mice, rigs and days too). The clean test is both people labelling the same sessions.</a:t>
+            </a:r>
+            <a:endParaRPr lang="en-US" sz="1400" dirty="0"/>
+          </a:p>
+        </p:txBody>
+      </p:sp>
+      <p:sp>
+        <p:nvSpPr>
+          <p:cNvPr id="25" name="Slide Number Placeholder 0"/>
+          <p:cNvSpPr>
+            <a:spLocks noGrp="1"/>
+          </p:cNvSpPr>
+          <p:nvPr>
+            <p:ph type="sldNum" sz="quarter" idx="4294967295"/>
+          </p:nvPr>
+        </p:nvSpPr>
+        <p:spPr>
+          <a:xfrm>
+            <a:off x="11185855" y="6400800"/>
+            <a:ext cx="457200" cy="274320"/>
+          </a:xfrm>
+          <a:prstGeom prst="rect">
+            <a:avLst/>
+          </a:prstGeom>
+          <a:extLst>
+            <a:ext uri="{C572A759-6A51-4108-AA02-DFA0A04FC94B}">
+              <ma14:wrappingTextBoxFlag xmlns:ma14="http://schemas.microsoft.com/office/mac/drawingml/2011/main" val="0"/>
+            </a:ext>
+          </a:extLst>
+        </p:spPr>
+        <p:txBody>
+          <a:bodyPr/>
+          <a:lstStyle>
+            <a:lvl1pPr>
+              <a:defRPr sz="1000">
+                <a:solidFill>
+                  <a:schemeClr val="accent4"/>
+                </a:solidFill>
+              </a:defRPr>
+            </a:lvl1pPr>
+          </a:lstStyle>
+          <a:p>
+            <a:pPr algn="r"/>
+            <a:fld id="{F7021451-1387-4CA6-816F-3879F97B5CBC}" type="slidenum">
+              <a:rPr b="0" lang="en-US"/>
+              <a:t>13</a:t>
+            </a:fld>
+            <a:endParaRPr lang="en-US"/>
+          </a:p>
+        </p:txBody>
+      </p:sp>
+    </p:spTree>
+  </p:cSld>
+  <p:clrMapOvr>
+    <a:masterClrMapping/>
+  </p:clrMapOvr>
+</p:sld>
+</file>
+
+<file path=ppt/slides/slide14.xml><?xml version="1.0" encoding="utf-8"?>
+<p:sld xmlns:a="http://schemas.openxmlformats.org/drawingml/2006/main" xmlns:r="http://schemas.openxmlformats.org/officeDocument/2006/relationships" xmlns:p="http://schemas.openxmlformats.org/presentationml/2006/main">
+  <p:cSld name="Slide 14">
+    <p:spTree>
+      <p:nvGrpSpPr>
+        <p:cNvPr id="1" name=""/>
+        <p:cNvGrpSpPr/>
+        <p:nvPr/>
+      </p:nvGrpSpPr>
+      <p:grpSpPr>
+        <a:xfrm>
+          <a:off x="0" y="0"/>
+          <a:ext cx="0" cy="0"/>
+          <a:chOff x="0" y="0"/>
+          <a:chExt cx="0" cy="0"/>
+        </a:xfrm>
+      </p:grpSpPr>
+      <p:sp>
+        <p:nvSpPr>
+          <p:cNvPr id="2" name="Text 0"/>
+          <p:cNvSpPr/>
+          <p:nvPr>
+            <p:ph idx="100" type="title" hasCustomPrompt="1"/>
+          </p:nvPr>
+        </p:nvSpPr>
+        <p:spPr>
+          <a:xfrm>
+            <a:off x="548640" y="320040"/>
+            <a:ext cx="11094415" cy="777240"/>
+          </a:xfrm>
+          <a:prstGeom prst="rect">
+            <a:avLst/>
+          </a:prstGeom>
+          <a:noFill/>
+          <a:ln/>
+        </p:spPr>
+        <p:txBody>
+          <a:bodyPr wrap="square" lIns="0" tIns="0" rIns="0" bIns="0" rtlCol="0" anchor="ctr"/>
+          <a:lstStyle/>
+          <a:p>
+            <a:pPr indent="0" marL="0">
+              <a:buNone/>
+            </a:pPr>
+            <a:r>
+              <a:rPr lang="en-US" sz="3000" b="1" dirty="0">
+                <a:solidFill>
+                  <a:schemeClr val="tx2"/>
+                </a:solidFill>
+                <a:latin typeface="Cambria" pitchFamily="34" charset="0"/>
+                <a:ea typeface="Cambria" pitchFamily="34" charset="-122"/>
+                <a:cs typeface="Cambria" pitchFamily="34" charset="-120"/>
+              </a:rPr>
+              <a:t>Within a lab, label strictness varies by session</a:t>
             </a:r>
             <a:endParaRPr lang="en-US" sz="3000" dirty="0"/>
           </a:p>
@@ -5287,7 +9221,7 @@
       </p:sp>
       <p:graphicFrame>
         <p:nvGraphicFramePr>
-          <p:cNvPr id="12" name="lab hold-out table"/>
+          <p:cNvPr id="15" name="lab hold-out table"/>
           <p:cNvGraphicFramePr>
             <a:graphicFrameLocks noGrp="1"/>
           </p:cNvGraphicFramePr>
@@ -6179,7 +10113,7 @@
             <a:pPr algn="r"/>
             <a:fld id="{F7021451-1387-4CA6-816F-3879F97B5CBC}" type="slidenum">
               <a:rPr b="0" lang="en-US"/>
-              <a:t>11</a:t>
+              <a:t>14</a:t>
             </a:fld>
             <a:endParaRPr lang="en-US"/>
           </a:p>
@@ -6193,9 +10127,9 @@
 </p:sld>
 </file>
 
-<file path=ppt/slides/slide12.xml><?xml version="1.0" encoding="utf-8"?>
+<file path=ppt/slides/slide15.xml><?xml version="1.0" encoding="utf-8"?>
 <p:sld xmlns:a="http://schemas.openxmlformats.org/drawingml/2006/main" xmlns:r="http://schemas.openxmlformats.org/officeDocument/2006/relationships" xmlns:p="http://schemas.openxmlformats.org/presentationml/2006/main">
-  <p:cSld name="Slide 12">
+  <p:cSld name="Slide 15">
     <p:spTree>
       <p:nvGrpSpPr>
         <p:cNvPr id="1" name=""/>
@@ -6877,7 +10811,7 @@
             <a:pPr algn="r"/>
             <a:fld id="{F7021451-1387-4CA6-816F-3879F97B5CBC}" type="slidenum">
               <a:rPr b="0" lang="en-US"/>
-              <a:t>12</a:t>
+              <a:t>15</a:t>
             </a:fld>
             <a:endParaRPr lang="en-US"/>
           </a:p>
@@ -6891,9 +10825,9 @@
 </p:sld>
 </file>
 
-<file path=ppt/slides/slide13.xml><?xml version="1.0" encoding="utf-8"?>
+<file path=ppt/slides/slide16.xml><?xml version="1.0" encoding="utf-8"?>
 <p:sld xmlns:a="http://schemas.openxmlformats.org/drawingml/2006/main" xmlns:r="http://schemas.openxmlformats.org/officeDocument/2006/relationships" xmlns:p="http://schemas.openxmlformats.org/presentationml/2006/main">
-  <p:cSld name="Slide 13">
+  <p:cSld name="Slide 16">
     <p:spTree>
       <p:nvGrpSpPr>
         <p:cNvPr id="1" name=""/>
@@ -6957,8 +10891,8 @@
         </p:nvSpPr>
         <p:spPr>
           <a:xfrm>
-            <a:off x="548640" y="1463040"/>
-            <a:ext cx="502920" cy="502920"/>
+            <a:off x="548640" y="1417320"/>
+            <a:ext cx="457200" cy="457200"/>
           </a:xfrm>
           <a:prstGeom prst="ellipse">
             <a:avLst/>
@@ -6977,8 +10911,8 @@
         </p:nvSpPr>
         <p:spPr>
           <a:xfrm>
-            <a:off x="548640" y="1463040"/>
-            <a:ext cx="502920" cy="502920"/>
+            <a:off x="548640" y="1417320"/>
+            <a:ext cx="457200" cy="457200"/>
           </a:xfrm>
           <a:prstGeom prst="rect">
             <a:avLst/>
@@ -6994,14 +10928,14 @@
               <a:buNone/>
             </a:pPr>
             <a:r>
-              <a:rPr lang="en-US" sz="1700" b="1" dirty="0">
+              <a:rPr lang="en-US" sz="1500" b="1" dirty="0">
                 <a:solidFill>
                   <a:schemeClr val="bg1"/>
                 </a:solidFill>
               </a:rPr>
               <a:t>1</a:t>
             </a:r>
-            <a:endParaRPr lang="en-US" sz="1700" dirty="0"/>
+            <a:endParaRPr lang="en-US" sz="1500" dirty="0"/>
           </a:p>
         </p:txBody>
       </p:sp>
@@ -7013,8 +10947,8 @@
         </p:nvSpPr>
         <p:spPr>
           <a:xfrm>
-            <a:off x="1325880" y="1417320"/>
-            <a:ext cx="10317175" cy="868680"/>
+            <a:off x="1280160" y="1371600"/>
+            <a:ext cx="10362895" cy="731520"/>
           </a:xfrm>
           <a:prstGeom prst="rect">
             <a:avLst/>
@@ -7030,28 +10964,28 @@
               <a:buNone/>
             </a:pPr>
             <a:r>
-              <a:rPr lang="en-US" sz="1900" b="1" dirty="0">
+              <a:rPr lang="en-US" sz="1800" b="1" dirty="0">
                 <a:solidFill>
                   <a:schemeClr val="bg1"/>
                 </a:solidFill>
               </a:rPr>
               <a:t>Ship the image preset</a:t>
             </a:r>
-            <a:endParaRPr lang="en-US" sz="1900" dirty="0"/>
+            <a:endParaRPr lang="en-US" sz="1800" dirty="0"/>
           </a:p>
           <a:p>
             <a:pPr indent="0" marL="0">
               <a:buNone/>
             </a:pPr>
             <a:r>
-              <a:rPr lang="en-US" sz="1500" dirty="0">
+              <a:rPr lang="en-US" sz="1400" dirty="0">
                 <a:solidFill>
                   <a:schemeClr val="accent6"/>
                 </a:solidFill>
               </a:rPr>
               <a:t>+0.026 F1, cheap, explainable with SHAP</a:t>
             </a:r>
-            <a:endParaRPr lang="en-US" sz="1900" dirty="0"/>
+            <a:endParaRPr lang="en-US" sz="1800" dirty="0"/>
           </a:p>
         </p:txBody>
       </p:sp>
@@ -7063,8 +10997,8 @@
         </p:nvSpPr>
         <p:spPr>
           <a:xfrm>
-            <a:off x="548640" y="2423160"/>
-            <a:ext cx="502920" cy="502920"/>
+            <a:off x="548640" y="2221992"/>
+            <a:ext cx="457200" cy="457200"/>
           </a:xfrm>
           <a:prstGeom prst="ellipse">
             <a:avLst/>
@@ -7083,8 +11017,8 @@
         </p:nvSpPr>
         <p:spPr>
           <a:xfrm>
-            <a:off x="548640" y="2423160"/>
-            <a:ext cx="502920" cy="502920"/>
+            <a:off x="548640" y="2221992"/>
+            <a:ext cx="457200" cy="457200"/>
           </a:xfrm>
           <a:prstGeom prst="rect">
             <a:avLst/>
@@ -7100,14 +11034,14 @@
               <a:buNone/>
             </a:pPr>
             <a:r>
-              <a:rPr lang="en-US" sz="1700" b="1" dirty="0">
+              <a:rPr lang="en-US" sz="1500" b="1" dirty="0">
                 <a:solidFill>
                   <a:schemeClr val="bg1"/>
                 </a:solidFill>
               </a:rPr>
               <a:t>2</a:t>
             </a:r>
-            <a:endParaRPr lang="en-US" sz="1700" dirty="0"/>
+            <a:endParaRPr lang="en-US" sz="1500" dirty="0"/>
           </a:p>
         </p:txBody>
       </p:sp>
@@ -7119,8 +11053,8 @@
         </p:nvSpPr>
         <p:spPr>
           <a:xfrm>
-            <a:off x="1325880" y="2377440"/>
-            <a:ext cx="10317175" cy="868680"/>
+            <a:off x="1280160" y="2176272"/>
+            <a:ext cx="10362895" cy="731520"/>
           </a:xfrm>
           <a:prstGeom prst="rect">
             <a:avLst/>
@@ -7136,28 +11070,28 @@
               <a:buNone/>
             </a:pPr>
             <a:r>
-              <a:rPr lang="en-US" sz="1900" b="1" dirty="0">
+              <a:rPr lang="en-US" sz="1800" b="1" dirty="0">
                 <a:solidFill>
                   <a:schemeClr val="bg1"/>
                 </a:solidFill>
               </a:rPr>
               <a:t>Review labels in Inbar3, inbar1, Stav14</a:t>
             </a:r>
-            <a:endParaRPr lang="en-US" sz="1900" dirty="0"/>
+            <a:endParaRPr lang="en-US" sz="1800" dirty="0"/>
           </a:p>
           <a:p>
             <a:pPr indent="0" marL="0">
               <a:buNone/>
             </a:pPr>
             <a:r>
-              <a:rPr lang="en-US" sz="1500" dirty="0">
+              <a:rPr lang="en-US" sz="1400" dirty="0">
                 <a:solidFill>
                   <a:schemeClr val="accent6"/>
                 </a:solidFill>
               </a:rPr>
               <a:t>Many 'errors' may be labelling calls; fixing them helps scoring and training</a:t>
             </a:r>
-            <a:endParaRPr lang="en-US" sz="1900" dirty="0"/>
+            <a:endParaRPr lang="en-US" sz="1800" dirty="0"/>
           </a:p>
         </p:txBody>
       </p:sp>
@@ -7169,8 +11103,8 @@
         </p:nvSpPr>
         <p:spPr>
           <a:xfrm>
-            <a:off x="548640" y="3383280"/>
-            <a:ext cx="502920" cy="502920"/>
+            <a:off x="548640" y="3026664"/>
+            <a:ext cx="457200" cy="457200"/>
           </a:xfrm>
           <a:prstGeom prst="ellipse">
             <a:avLst/>
@@ -7189,8 +11123,8 @@
         </p:nvSpPr>
         <p:spPr>
           <a:xfrm>
-            <a:off x="548640" y="3383280"/>
-            <a:ext cx="502920" cy="502920"/>
+            <a:off x="548640" y="3026664"/>
+            <a:ext cx="457200" cy="457200"/>
           </a:xfrm>
           <a:prstGeom prst="rect">
             <a:avLst/>
@@ -7206,14 +11140,14 @@
               <a:buNone/>
             </a:pPr>
             <a:r>
-              <a:rPr lang="en-US" sz="1700" b="1" dirty="0">
+              <a:rPr lang="en-US" sz="1500" b="1" dirty="0">
                 <a:solidFill>
                   <a:schemeClr val="bg1"/>
                 </a:solidFill>
               </a:rPr>
               <a:t>3</a:t>
             </a:r>
-            <a:endParaRPr lang="en-US" sz="1700" dirty="0"/>
+            <a:endParaRPr lang="en-US" sz="1500" dirty="0"/>
           </a:p>
         </p:txBody>
       </p:sp>
@@ -7225,8 +11159,8 @@
         </p:nvSpPr>
         <p:spPr>
           <a:xfrm>
-            <a:off x="1325880" y="3337560"/>
-            <a:ext cx="10317175" cy="868680"/>
+            <a:off x="1280160" y="2980944"/>
+            <a:ext cx="10362895" cy="731520"/>
           </a:xfrm>
           <a:prstGeom prst="rect">
             <a:avLst/>
@@ -7242,28 +11176,28 @@
               <a:buNone/>
             </a:pPr>
             <a:r>
-              <a:rPr lang="en-US" sz="1900" b="1" dirty="0">
+              <a:rPr lang="en-US" sz="1800" b="1" dirty="0">
                 <a:solidFill>
                   <a:schemeClr val="bg1"/>
                 </a:solidFill>
               </a:rPr>
-              <a:t>Use a per-lab or per-session threshold</a:t>
-            </a:r>
-            <a:endParaRPr lang="en-US" sz="1900" dirty="0"/>
+              <a:t>Use a per-lab threshold, and train on each lab's own labels when there is enough</a:t>
+            </a:r>
+            <a:endParaRPr lang="en-US" sz="1800" dirty="0"/>
           </a:p>
           <a:p>
             <a:pPr indent="0" marL="0">
               <a:buNone/>
             </a:pPr>
             <a:r>
-              <a:rPr lang="en-US" sz="1500" dirty="0">
+              <a:rPr lang="en-US" sz="1400" dirty="0">
                 <a:solidFill>
                   <a:schemeClr val="accent6"/>
                 </a:solidFill>
               </a:rPr>
-              <a:t>Worth about +0.015–0.04 F1 on Inbar sessions; the dashboard slider already allows it</a:t>
-            </a:r>
-            <a:endParaRPr lang="en-US" sz="1900" dirty="0"/>
+              <a:t>Own-lab training wins by up to +0.04 F1; the dashboard slider already allows a different threshold</a:t>
+            </a:r>
+            <a:endParaRPr lang="en-US" sz="1800" dirty="0"/>
           </a:p>
         </p:txBody>
       </p:sp>
@@ -7275,8 +11209,8 @@
         </p:nvSpPr>
         <p:spPr>
           <a:xfrm>
-            <a:off x="548640" y="4343400"/>
-            <a:ext cx="502920" cy="502920"/>
+            <a:off x="548640" y="3831336"/>
+            <a:ext cx="457200" cy="457200"/>
           </a:xfrm>
           <a:prstGeom prst="ellipse">
             <a:avLst/>
@@ -7295,8 +11229,8 @@
         </p:nvSpPr>
         <p:spPr>
           <a:xfrm>
-            <a:off x="548640" y="4343400"/>
-            <a:ext cx="502920" cy="502920"/>
+            <a:off x="548640" y="3831336"/>
+            <a:ext cx="457200" cy="457200"/>
           </a:xfrm>
           <a:prstGeom prst="rect">
             <a:avLst/>
@@ -7312,14 +11246,14 @@
               <a:buNone/>
             </a:pPr>
             <a:r>
-              <a:rPr lang="en-US" sz="1700" b="1" dirty="0">
+              <a:rPr lang="en-US" sz="1500" b="1" dirty="0">
                 <a:solidFill>
                   <a:schemeClr val="bg1"/>
                 </a:solidFill>
               </a:rPr>
               <a:t>4</a:t>
             </a:r>
-            <a:endParaRPr lang="en-US" sz="1700" dirty="0"/>
+            <a:endParaRPr lang="en-US" sz="1500" dirty="0"/>
           </a:p>
         </p:txBody>
       </p:sp>
@@ -7331,8 +11265,8 @@
         </p:nvSpPr>
         <p:spPr>
           <a:xfrm>
-            <a:off x="1325880" y="4297680"/>
-            <a:ext cx="10317175" cy="868680"/>
+            <a:off x="1280160" y="3785616"/>
+            <a:ext cx="10362895" cy="731520"/>
           </a:xfrm>
           <a:prstGeom prst="rect">
             <a:avLst/>
@@ -7348,28 +11282,28 @@
               <a:buNone/>
             </a:pPr>
             <a:r>
-              <a:rPr lang="en-US" sz="1900" b="1" dirty="0">
+              <a:rPr lang="en-US" sz="1800" b="1" dirty="0">
                 <a:solidFill>
                   <a:schemeClr val="bg1"/>
                 </a:solidFill>
               </a:rPr>
-              <a:t>Add the CNN only if 0.007 matters</a:t>
-            </a:r>
-            <a:endParaRPr lang="en-US" sz="1900" dirty="0"/>
+              <a:t>Measure labeller agreement directly</a:t>
+            </a:r>
+            <a:endParaRPr lang="en-US" sz="1800" dirty="0"/>
           </a:p>
           <a:p>
             <a:pPr indent="0" marL="0">
               <a:buNone/>
             </a:pPr>
             <a:r>
-              <a:rPr lang="en-US" sz="1500" dirty="0">
+              <a:rPr lang="en-US" sz="1400" dirty="0">
                 <a:solidFill>
                   <a:schemeClr val="accent6"/>
                 </a:solidFill>
               </a:rPr>
-              <a:t>Best model is 0.861, but needs a CNN at inference</a:t>
-            </a:r>
-            <a:endParaRPr lang="en-US" sz="1900" dirty="0"/>
+              <a:t>Have Stav and Inbar label the same 2–3 sessions; this separates labelling style from recording differences</a:t>
+            </a:r>
+            <a:endParaRPr lang="en-US" sz="1800" dirty="0"/>
           </a:p>
         </p:txBody>
       </p:sp>
@@ -7381,8 +11315,8 @@
         </p:nvSpPr>
         <p:spPr>
           <a:xfrm>
-            <a:off x="548640" y="5303520"/>
-            <a:ext cx="502920" cy="502920"/>
+            <a:off x="548640" y="4636008"/>
+            <a:ext cx="457200" cy="457200"/>
           </a:xfrm>
           <a:prstGeom prst="ellipse">
             <a:avLst/>
@@ -7401,8 +11335,8 @@
         </p:nvSpPr>
         <p:spPr>
           <a:xfrm>
-            <a:off x="548640" y="5303520"/>
-            <a:ext cx="502920" cy="502920"/>
+            <a:off x="548640" y="4636008"/>
+            <a:ext cx="457200" cy="457200"/>
           </a:xfrm>
           <a:prstGeom prst="rect">
             <a:avLst/>
@@ -7418,14 +11352,14 @@
               <a:buNone/>
             </a:pPr>
             <a:r>
-              <a:rPr lang="en-US" sz="1700" b="1" dirty="0">
+              <a:rPr lang="en-US" sz="1500" b="1" dirty="0">
                 <a:solidFill>
                   <a:schemeClr val="bg1"/>
                 </a:solidFill>
               </a:rPr>
               <a:t>5</a:t>
             </a:r>
-            <a:endParaRPr lang="en-US" sz="1700" dirty="0"/>
+            <a:endParaRPr lang="en-US" sz="1500" dirty="0"/>
           </a:p>
         </p:txBody>
       </p:sp>
@@ -7437,8 +11371,8 @@
         </p:nvSpPr>
         <p:spPr>
           <a:xfrm>
-            <a:off x="1325880" y="5257800"/>
-            <a:ext cx="10317175" cy="868680"/>
+            <a:off x="1280160" y="4590288"/>
+            <a:ext cx="10362895" cy="731520"/>
           </a:xfrm>
           <a:prstGeom prst="rect">
             <a:avLst/>
@@ -7454,28 +11388,134 @@
               <a:buNone/>
             </a:pPr>
             <a:r>
-              <a:rPr lang="en-US" sz="1900" b="1" dirty="0">
+              <a:rPr lang="en-US" sz="1800" b="1" dirty="0">
                 <a:solidFill>
                   <a:schemeClr val="bg1"/>
                 </a:solidFill>
               </a:rPr>
-              <a:t>Fix the regular model's feature mismatch</a:t>
-            </a:r>
-            <a:endParaRPr lang="en-US" sz="1900" dirty="0"/>
+              <a:t>Add the CNN only if 0.007 matters</a:t>
+            </a:r>
+            <a:endParaRPr lang="en-US" sz="1800" dirty="0"/>
           </a:p>
           <a:p>
             <a:pPr indent="0" marL="0">
               <a:buNone/>
             </a:pPr>
             <a:r>
-              <a:rPr lang="en-US" sz="1500" dirty="0">
+              <a:rPr lang="en-US" sz="1400" dirty="0">
                 <a:solidFill>
                   <a:schemeClr val="accent6"/>
                 </a:solidFill>
               </a:rPr>
+              <a:t>Best model is 0.861, but needs a CNN at inference</a:t>
+            </a:r>
+            <a:endParaRPr lang="en-US" sz="1800" dirty="0"/>
+          </a:p>
+        </p:txBody>
+      </p:sp>
+      <p:sp>
+        <p:nvSpPr>
+          <p:cNvPr id="18" name="recommendation 6 dot"/>
+          <p:cNvSpPr/>
+          <p:nvPr/>
+        </p:nvSpPr>
+        <p:spPr>
+          <a:xfrm>
+            <a:off x="548640" y="5440680"/>
+            <a:ext cx="457200" cy="457200"/>
+          </a:xfrm>
+          <a:prstGeom prst="ellipse">
+            <a:avLst/>
+          </a:prstGeom>
+          <a:solidFill>
+            <a:schemeClr val="accent1"/>
+          </a:solidFill>
+          <a:ln/>
+        </p:spPr>
+      </p:sp>
+      <p:sp>
+        <p:nvSpPr>
+          <p:cNvPr id="19" name="recommendation 6 num"/>
+          <p:cNvSpPr txBox="1"/>
+          <p:nvPr/>
+        </p:nvSpPr>
+        <p:spPr>
+          <a:xfrm>
+            <a:off x="548640" y="5440680"/>
+            <a:ext cx="457200" cy="457200"/>
+          </a:xfrm>
+          <a:prstGeom prst="rect">
+            <a:avLst/>
+          </a:prstGeom>
+          <a:noFill/>
+          <a:ln/>
+        </p:spPr>
+        <p:txBody>
+          <a:bodyPr wrap="square" lIns="0" tIns="0" rIns="0" bIns="0" rtlCol="0" anchor="ctr"/>
+          <a:lstStyle/>
+          <a:p>
+            <a:pPr algn="ctr" indent="0" marL="0">
+              <a:buNone/>
+            </a:pPr>
+            <a:r>
+              <a:rPr lang="en-US" sz="1500" b="1" dirty="0">
+                <a:solidFill>
+                  <a:schemeClr val="bg1"/>
+                </a:solidFill>
+              </a:rPr>
+              <a:t>6</a:t>
+            </a:r>
+            <a:endParaRPr lang="en-US" sz="1500" dirty="0"/>
+          </a:p>
+        </p:txBody>
+      </p:sp>
+      <p:sp>
+        <p:nvSpPr>
+          <p:cNvPr id="20" name="recommendation 6 text"/>
+          <p:cNvSpPr txBox="1"/>
+          <p:nvPr/>
+        </p:nvSpPr>
+        <p:spPr>
+          <a:xfrm>
+            <a:off x="1280160" y="5394960"/>
+            <a:ext cx="10362895" cy="731520"/>
+          </a:xfrm>
+          <a:prstGeom prst="rect">
+            <a:avLst/>
+          </a:prstGeom>
+          <a:noFill/>
+          <a:ln/>
+        </p:spPr>
+        <p:txBody>
+          <a:bodyPr wrap="square" lIns="0" tIns="0" rIns="0" bIns="0" rtlCol="0" anchor="t"/>
+          <a:lstStyle/>
+          <a:p>
+            <a:pPr indent="0" marL="0">
+              <a:buNone/>
+            </a:pPr>
+            <a:r>
+              <a:rPr lang="en-US" sz="1800" b="1" dirty="0">
+                <a:solidFill>
+                  <a:schemeClr val="bg1"/>
+                </a:solidFill>
+              </a:rPr>
+              <a:t>Fix the regular model's feature mismatch</a:t>
+            </a:r>
+            <a:endParaRPr lang="en-US" sz="1800" dirty="0"/>
+          </a:p>
+          <a:p>
+            <a:pPr indent="0" marL="0">
+              <a:buNone/>
+            </a:pPr>
+            <a:r>
+              <a:rPr lang="en-US" sz="1400" dirty="0">
+                <a:solidFill>
+                  <a:schemeClr val="accent6"/>
+                </a:solidFill>
+              </a:rPr>
               <a:t>Its cached quantile features are scaled differently at training and inference</a:t>
             </a:r>
-            <a:endParaRPr lang="en-US" sz="1900" dirty="0"/>
+            <a:endParaRPr lang="en-US" sz="1800" dirty="0"/>
           </a:p>
         </p:txBody>
       </p:sp>
@@ -7518,7 +11558,7 @@
             <a:pPr algn="r"/>
             <a:fld id="{F7021451-1387-4CA6-816F-3879F97B5CBC}" type="slidenum">
               <a:rPr b="0" lang="en-US"/>
-              <a:t>13</a:t>
+              <a:t>16</a:t>
             </a:fld>
             <a:endParaRPr lang="en-US"/>
           </a:p>
@@ -8115,7 +12155,7 @@
                   <a:schemeClr val="tx2"/>
                 </a:solidFill>
               </a:rPr>
-              <a:t>The hardest sessions are a labelling-style problem</a:t>
+              <a:t>Who labelled the data matters</a:t>
             </a:r>
             <a:endParaRPr lang="en-US" sz="1700" dirty="0"/>
           </a:p>
@@ -8129,7 +12169,7 @@
                   <a:schemeClr val="tx1"/>
                 </a:solidFill>
               </a:rPr>
-              <a:t>Inbar3, inbar1 and Stav14 rank well (0.82–0.88 F1 at their own best threshold) but were labelled more or less strictly</a:t>
+              <a:t>Stav-trained models score best on Stav sessions in 4 of 4 tests; on the hardest Inbar sessions an Inbar-trained model wins by 0.04</a:t>
             </a:r>
             <a:endParaRPr lang="en-US" sz="1700" dirty="0"/>
           </a:p>

</xml_diff>

<commit_message>
Deck: call the 27-feature model 'previous', not 'current'
Co-Authored-By: Claude Opus 5.5 (1M context) <noreply@anthropic.com>
</commit_message>
<xml_diff>
--- a/results/suite2p_roi_classification_summary.pptx
+++ b/results/suite2p_roi_classification_summary.pptx
@@ -122,19 +122,19 @@
   <p:extLst>
     <p:ext uri="{521415D9-36F7-43E2-AB2F-B90AF26B5E84}">
       <p14:sectionLst xmlns:p14="http://schemas.microsoft.com/office/powerpoint/2010/main">
-        <p14:section name="Overview" id="{c7c191e7-ea14-12f3-0235-c88a6d6834af}">
+        <p14:section name="Overview" id="{4581bc7d-4ec3-843a-fc04-757443538060}">
           <p14:sldIdLst>
             <p14:sldId id="256"/>
             <p14:sldId id="257"/>
           </p14:sldIdLst>
         </p14:section>
-        <p14:section name="Data and evaluation" id="{2e41463d-2fe1-2c97-1f41-8e4377e1b978}">
+        <p14:section name="Data and evaluation" id="{2e916c09-0c70-a503-c1e7-68663fc73086}">
           <p14:sldIdLst>
             <p14:sldId id="258"/>
             <p14:sldId id="259"/>
           </p14:sldIdLst>
         </p14:section>
-        <p14:section name="Image features" id="{7acb0ec1-4d6c-b350-c6f9-e6e5218aaa37}">
+        <p14:section name="Image features" id="{0fb1f232-e86e-99bd-60a0-4669e5becae0}">
           <p14:sldIdLst>
             <p14:sldId id="260"/>
             <p14:sldId id="261"/>
@@ -142,13 +142,13 @@
             <p14:sldId id="263"/>
           </p14:sldIdLst>
         </p14:section>
-        <p14:section name="Neural networks and alternatives" id="{f39e3c94-5f0d-e7e7-44c2-d9da65484fd1}">
+        <p14:section name="Neural networks and alternatives" id="{8f8db071-7b15-4381-e1db-8e7840a0b974}">
           <p14:sldIdLst>
             <p14:sldId id="264"/>
             <p14:sldId id="265"/>
           </p14:sldIdLst>
         </p14:section>
-        <p14:section name="Labels" id="{c9ebb9e3-90ed-71a1-46fe-37b6358c25f0}">
+        <p14:section name="Labels" id="{3e9a3860-8062-074a-6c21-c25093ad2970}">
           <p14:sldIdLst>
             <p14:sldId id="266"/>
             <p14:sldId id="267"/>
@@ -156,7 +156,7 @@
             <p14:sldId id="269"/>
           </p14:sldIdLst>
         </p14:section>
-        <p14:section name="Next steps" id="{35df7b02-f4a3-697c-c1b1-8e543222a7ab}">
+        <p14:section name="Next steps" id="{1d59182c-0e11-8227-4f2e-a8a61f717cee}">
           <p14:sldIdLst>
             <p14:sldId id="270"/>
             <p14:sldId id="271"/>
@@ -10254,7 +10254,7 @@
                   <a:schemeClr val="accent6"/>
                 </a:solidFill>
               </a:rPr>
-              <a:t>Without 'image', the current model runs exactly as before; nothing in models/ or any iscell file was changed</a:t>
+              <a:t>Without 'image', the previous 27-feature model runs exactly as before; nothing in models/ or any iscell file was changed</a:t>
             </a:r>
             <a:endParaRPr lang="en-US" sz="2000" dirty="0"/>
           </a:p>
@@ -11721,7 +11721,7 @@
                   <a:schemeClr val="tx1"/>
                 </a:solidFill>
               </a:rPr>
-              <a:t>Current 27-feature model</a:t>
+              <a:t>Previous 27-feature model</a:t>
             </a:r>
             <a:endParaRPr lang="en-US" sz="1800" dirty="0"/>
           </a:p>
@@ -14463,7 +14463,7 @@
                   <a:schemeClr val="tx2"/>
                 </a:solidFill>
               </a:rPr>
-              <a:t>The 10 lowest-scoring sessions under the current model. </a:t>
+              <a:t>The 10 lowest-scoring sessions under the previous 27-feature model. </a:t>
             </a:r>
             <a:pPr indent="0" marL="0">
               <a:buNone/>

</xml_diff>